<commit_message>
minor slide reorg (after class)
</commit_message>
<xml_diff>
--- a/slides/11-logistic-regression.pptx
+++ b/slides/11-logistic-regression.pptx
@@ -5,28 +5,27 @@
     <p:sldMasterId id="2147483686" r:id="rId1"/>
   </p:sldMasterIdLst>
   <p:notesMasterIdLst>
-    <p:notesMasterId r:id="rId21"/>
+    <p:notesMasterId r:id="rId20"/>
   </p:notesMasterIdLst>
   <p:sldIdLst>
     <p:sldId id="256" r:id="rId2"/>
-    <p:sldId id="257" r:id="rId3"/>
-    <p:sldId id="295" r:id="rId4"/>
-    <p:sldId id="294" r:id="rId5"/>
+    <p:sldId id="295" r:id="rId3"/>
+    <p:sldId id="294" r:id="rId4"/>
+    <p:sldId id="288" r:id="rId5"/>
     <p:sldId id="289" r:id="rId6"/>
-    <p:sldId id="288" r:id="rId7"/>
-    <p:sldId id="291" r:id="rId8"/>
-    <p:sldId id="297" r:id="rId9"/>
-    <p:sldId id="296" r:id="rId10"/>
-    <p:sldId id="259" r:id="rId11"/>
-    <p:sldId id="260" r:id="rId12"/>
-    <p:sldId id="261" r:id="rId13"/>
-    <p:sldId id="301" r:id="rId14"/>
-    <p:sldId id="262" r:id="rId15"/>
-    <p:sldId id="298" r:id="rId16"/>
-    <p:sldId id="263" r:id="rId17"/>
-    <p:sldId id="299" r:id="rId18"/>
-    <p:sldId id="292" r:id="rId19"/>
-    <p:sldId id="264" r:id="rId20"/>
+    <p:sldId id="291" r:id="rId7"/>
+    <p:sldId id="297" r:id="rId8"/>
+    <p:sldId id="296" r:id="rId9"/>
+    <p:sldId id="259" r:id="rId10"/>
+    <p:sldId id="260" r:id="rId11"/>
+    <p:sldId id="261" r:id="rId12"/>
+    <p:sldId id="301" r:id="rId13"/>
+    <p:sldId id="262" r:id="rId14"/>
+    <p:sldId id="298" r:id="rId15"/>
+    <p:sldId id="263" r:id="rId16"/>
+    <p:sldId id="299" r:id="rId17"/>
+    <p:sldId id="292" r:id="rId18"/>
+    <p:sldId id="264" r:id="rId19"/>
   </p:sldIdLst>
   <p:sldSz cx="12192000" cy="6858000"/>
   <p:notesSz cx="6858000" cy="9144000"/>
@@ -215,7 +214,7 @@
           <a:p>
             <a:fld id="{A5320152-7289-42ED-97D3-BBB411F9F8C0}" type="datetimeFigureOut">
               <a:rPr lang="en-US" smtClean="0"/>
-              <a:t>9/23/2026</a:t>
+              <a:t>10/20/2026</a:t>
             </a:fld>
             <a:endParaRPr lang="en-US"/>
           </a:p>
@@ -564,31 +563,23 @@
           <a:p>
             <a:r>
               <a:rPr lang="en-US" dirty="0"/>
-              <a:t>The Bernoulli assumption is what earns us a likelihood — loss, optimization, </a:t>
+              <a:t>Show the exponent trick</a:t>
             </a:r>
             <a:r>
               <a:rPr lang="en-US"/>
-              <a:t>and </a:t>
+              <a:t>, then</a:t>
             </a:r>
             <a:r>
               <a:rPr lang="en-US" dirty="0"/>
-              <a:t>inference</a:t>
+              <a:t> make the punchline explicit: maximum likelihood and minimum cross-entropy are the same optimization</a:t>
             </a:r>
             <a:r>
               <a:rPr lang="en-US"/>
-              <a:t> all follow </a:t>
+              <a:t>. Use a badly-scored Default customer to make the loss concrete</a:t>
             </a:r>
             <a:r>
               <a:rPr lang="en-US" dirty="0"/>
-              <a:t>from this</a:t>
-            </a:r>
-            <a:r>
-              <a:rPr lang="en-US"/>
-              <a:t> one</a:t>
-            </a:r>
-            <a:r>
-              <a:rPr lang="en-US" dirty="0"/>
-              <a:t> line.</a:t>
+              <a:t>.</a:t>
             </a:r>
             <a:endParaRPr lang="en-US"/>
           </a:p>
@@ -636,19 +627,35 @@
           <a:p>
             <a:r>
               <a:rPr lang="en-US" dirty="0"/>
-              <a:t>Show the exponent trick</a:t>
+              <a:t>Convexity is </a:t>
             </a:r>
             <a:r>
               <a:rPr lang="en-US"/>
-              <a:t>, then</a:t>
+              <a:t>why </a:t>
             </a:r>
             <a:r>
               <a:rPr lang="en-US" dirty="0"/>
-              <a:t> make the punchline explicit: maximum likelihood and minimum cross-entropy are the same optimization</a:t>
+              <a:t>we can be relaxed about initialization and local minima. Contrast with neural networks</a:t>
             </a:r>
             <a:r>
               <a:rPr lang="en-US"/>
-              <a:t>. Use a badly-scored Default customer to make the loss concrete</a:t>
+              <a:t>. Flag the regularization preview so </a:t>
+            </a:r>
+            <a:r>
+              <a:rPr lang="en-US" dirty="0"/>
+              <a:t>the </a:t>
+            </a:r>
+            <a:r>
+              <a:rPr lang="en-US"/>
+              <a:t>closing slide </a:t>
+            </a:r>
+            <a:r>
+              <a:rPr lang="en-US" dirty="0"/>
+              <a:t>is </a:t>
+            </a:r>
+            <a:r>
+              <a:rPr lang="en-US"/>
+              <a:t>not a surprise</a:t>
             </a:r>
             <a:r>
               <a:rPr lang="en-US" dirty="0"/>
@@ -700,39 +707,7 @@
           <a:p>
             <a:r>
               <a:rPr lang="en-US" dirty="0"/>
-              <a:t>Convexity is </a:t>
-            </a:r>
-            <a:r>
-              <a:rPr lang="en-US"/>
-              <a:t>why </a:t>
-            </a:r>
-            <a:r>
-              <a:rPr lang="en-US" dirty="0"/>
-              <a:t>we can be relaxed about initialization and local minima. Contrast with neural networks</a:t>
-            </a:r>
-            <a:r>
-              <a:rPr lang="en-US"/>
-              <a:t>. Flag the regularization preview so </a:t>
-            </a:r>
-            <a:r>
-              <a:rPr lang="en-US" dirty="0"/>
-              <a:t>the </a:t>
-            </a:r>
-            <a:r>
-              <a:rPr lang="en-US"/>
-              <a:t>closing slide </a:t>
-            </a:r>
-            <a:r>
-              <a:rPr lang="en-US" dirty="0"/>
-              <a:t>is </a:t>
-            </a:r>
-            <a:r>
-              <a:rPr lang="en-US"/>
-              <a:t>not a surprise</a:t>
-            </a:r>
-            <a:r>
-              <a:rPr lang="en-US" dirty="0"/>
-              <a:t>.</a:t>
+              <a:t>The (p − y) form is the memorable takeaway: same update shape as linear regression, with probabilities in place of fitted values.</a:t>
             </a:r>
             <a:endParaRPr lang="en-US"/>
           </a:p>
@@ -779,10 +754,9 @@
           <a:lstStyle/>
           <a:p>
             <a:r>
-              <a:rPr lang="en-US" dirty="0"/>
-              <a:t>The (p − y) form is the memorable takeaway: same update shape as linear regression, with probabilities in place of fitted values.</a:t>
-            </a:r>
-            <a:endParaRPr lang="en-US"/>
+              <a:rPr lang="en-US"/>
+              <a:t>Signpost. The model is fitted; everything left is deployment and evaluation.</a:t>
+            </a:r>
           </a:p>
         </p:txBody>
       </p:sp>
@@ -828,8 +802,37 @@
           <a:p>
             <a:r>
               <a:rPr lang="en-US"/>
-              <a:t>Signpost. The model is fitted; everything left is deployment and evaluation.</a:t>
-            </a:r>
+              <a:t>Separate </a:t>
+            </a:r>
+            <a:r>
+              <a:rPr lang="en-US" dirty="0"/>
+              <a:t>the </a:t>
+            </a:r>
+            <a:r>
+              <a:rPr lang="en-US"/>
+              <a:t>model </a:t>
+            </a:r>
+            <a:r>
+              <a:rPr lang="en-US" dirty="0"/>
+              <a:t>from </a:t>
+            </a:r>
+            <a:r>
+              <a:rPr lang="en-US"/>
+              <a:t>the decision rule. Emphasize </a:t>
+            </a:r>
+            <a:r>
+              <a:rPr lang="en-US" dirty="0"/>
+              <a:t>that</a:t>
+            </a:r>
+            <a:r>
+              <a:rPr lang="en-US"/>
+              <a:t> τ is chosen after fitting and can be changed freely</a:t>
+            </a:r>
+            <a:r>
+              <a:rPr lang="en-US" dirty="0"/>
+              <a:t>.</a:t>
+            </a:r>
+            <a:endParaRPr lang="en-US"/>
           </a:p>
         </p:txBody>
       </p:sp>
@@ -875,37 +878,8 @@
           <a:p>
             <a:r>
               <a:rPr lang="en-US"/>
-              <a:t>Separate </a:t>
-            </a:r>
-            <a:r>
-              <a:rPr lang="en-US" dirty="0"/>
-              <a:t>the </a:t>
-            </a:r>
-            <a:r>
-              <a:rPr lang="en-US"/>
-              <a:t>model </a:t>
-            </a:r>
-            <a:r>
-              <a:rPr lang="en-US" dirty="0"/>
-              <a:t>from </a:t>
-            </a:r>
-            <a:r>
-              <a:rPr lang="en-US"/>
-              <a:t>the decision rule. Emphasize </a:t>
-            </a:r>
-            <a:r>
-              <a:rPr lang="en-US" dirty="0"/>
-              <a:t>that</a:t>
-            </a:r>
-            <a:r>
-              <a:rPr lang="en-US"/>
-              <a:t> τ is chosen after fitting and can be changed freely</a:t>
-            </a:r>
-            <a:r>
-              <a:rPr lang="en-US" dirty="0"/>
-              <a:t>.</a:t>
-            </a:r>
-            <a:endParaRPr lang="en-US"/>
+              <a:t>Ask the class which errors are expensive in their own domain, then set τ from that. Define false positive and false negative explicitly before the ROC preview.</a:t>
+            </a:r>
           </a:p>
         </p:txBody>
       </p:sp>
@@ -950,9 +924,42 @@
           <a:lstStyle/>
           <a:p>
             <a:r>
+              <a:rPr lang="en-US" dirty="0"/>
+              <a:t>Work </a:t>
+            </a:r>
+            <a:r>
               <a:rPr lang="en-US"/>
-              <a:t>Ask the class which errors are expensive in their own domain, then set τ from that. Define false positive and false negative explicitly before the ROC preview.</a:t>
-            </a:r>
+              <a:t>steps 1–3 </a:t>
+            </a:r>
+            <a:r>
+              <a:rPr lang="en-US" dirty="0"/>
+              <a:t>on the board</a:t>
+            </a:r>
+            <a:r>
+              <a:rPr lang="en-US"/>
+              <a:t>, then give the class two minutes on the closing questions. Answers: at x = 4.0, z = 1.0 and p ≈ 0.73 ⇒ predict default; any τ below about 0.047 flips the $2,000 case</a:t>
+            </a:r>
+            <a:r>
+              <a:rPr lang="en-US" dirty="0"/>
+              <a:t>. Numbers are illustrative, </a:t>
+            </a:r>
+            <a:r>
+              <a:rPr lang="en-US"/>
+              <a:t>in the spirit of </a:t>
+            </a:r>
+            <a:r>
+              <a:rPr lang="en-US" dirty="0"/>
+              <a:t>the </a:t>
+            </a:r>
+            <a:r>
+              <a:rPr lang="en-US"/>
+              <a:t>Default example in James et al</a:t>
+            </a:r>
+            <a:r>
+              <a:rPr lang="en-US" dirty="0"/>
+              <a:t>.</a:t>
+            </a:r>
+            <a:endParaRPr lang="en-US"/>
           </a:p>
         </p:txBody>
       </p:sp>
@@ -997,86 +1004,6 @@
           <a:lstStyle/>
           <a:p>
             <a:r>
-              <a:rPr lang="en-US" dirty="0"/>
-              <a:t>Work </a:t>
-            </a:r>
-            <a:r>
-              <a:rPr lang="en-US"/>
-              <a:t>steps 1–3 </a:t>
-            </a:r>
-            <a:r>
-              <a:rPr lang="en-US" dirty="0"/>
-              <a:t>on the board</a:t>
-            </a:r>
-            <a:r>
-              <a:rPr lang="en-US"/>
-              <a:t>, then give the class two minutes on the closing questions. Answers: at x = 4.0, z = 1.0 and p ≈ 0.73 ⇒ predict default; any τ below about 0.047 flips the $2,000 case</a:t>
-            </a:r>
-            <a:r>
-              <a:rPr lang="en-US" dirty="0"/>
-              <a:t>. Numbers are illustrative, </a:t>
-            </a:r>
-            <a:r>
-              <a:rPr lang="en-US"/>
-              <a:t>in the spirit of </a:t>
-            </a:r>
-            <a:r>
-              <a:rPr lang="en-US" dirty="0"/>
-              <a:t>the </a:t>
-            </a:r>
-            <a:r>
-              <a:rPr lang="en-US"/>
-              <a:t>Default example in James et al</a:t>
-            </a:r>
-            <a:r>
-              <a:rPr lang="en-US" dirty="0"/>
-              <a:t>.</a:t>
-            </a:r>
-            <a:endParaRPr lang="en-US"/>
-          </a:p>
-        </p:txBody>
-      </p:sp>
-    </p:spTree>
-  </p:cSld>
-  <p:clrMapOvr>
-    <a:masterClrMapping/>
-  </p:clrMapOvr>
-</p:notes>
-</file>
-
-<file path=ppt/notesSlides/notesSlide18.xml><?xml version="1.0" encoding="utf-8"?>
-<p:notes xmlns:a="http://schemas.openxmlformats.org/drawingml/2006/main" xmlns:r="http://schemas.openxmlformats.org/officeDocument/2006/relationships" xmlns:p="http://schemas.openxmlformats.org/presentationml/2006/main">
-  <p:cSld>
-    <p:spTree>
-      <p:nvGrpSpPr>
-        <p:cNvPr id="1" name=""/>
-        <p:cNvGrpSpPr/>
-        <p:nvPr/>
-      </p:nvGrpSpPr>
-      <p:grpSpPr>
-        <a:xfrm>
-          <a:off x="0" y="0"/>
-          <a:ext cx="0" cy="0"/>
-          <a:chOff x="0" y="0"/>
-          <a:chExt cx="0" cy="0"/>
-        </a:xfrm>
-      </p:grpSpPr>
-      <p:sp>
-        <p:nvSpPr>
-          <p:cNvPr id="2" name="Notes Placeholder 1"/>
-          <p:cNvSpPr>
-            <a:spLocks noGrp="1"/>
-          </p:cNvSpPr>
-          <p:nvPr>
-            <p:ph type="body" idx="1"/>
-          </p:nvPr>
-        </p:nvSpPr>
-        <p:spPr/>
-        <p:txBody>
-          <a:bodyPr/>
-          <a:lstStyle/>
-          <a:p>
-            <a:r>
               <a:rPr lang="en-US"/>
               <a:t>Walk </a:t>
             </a:r>
@@ -1138,45 +1065,8 @@
           <a:p>
             <a:r>
               <a:rPr lang="en-US"/>
-              <a:t>Set expectations up front</a:t>
-            </a:r>
-            <a:r>
-              <a:rPr lang="en-US" dirty="0"/>
-              <a:t>. </a:t>
-            </a:r>
-            <a:r>
-              <a:rPr lang="en-US"/>
-              <a:t>The three parts map to three questions</a:t>
-            </a:r>
-            <a:r>
-              <a:rPr lang="en-US" dirty="0"/>
-              <a:t>: what </a:t>
-            </a:r>
-            <a:r>
-              <a:rPr lang="en-US"/>
-              <a:t>is the model, how do </a:t>
-            </a:r>
-            <a:r>
-              <a:rPr lang="en-US" dirty="0"/>
-              <a:t>we fit </a:t>
-            </a:r>
-            <a:r>
-              <a:rPr lang="en-US"/>
-              <a:t>it, how do we use it. Point </a:t>
-            </a:r>
-            <a:r>
-              <a:rPr lang="en-US" dirty="0"/>
-              <a:t>at </a:t>
-            </a:r>
-            <a:r>
-              <a:rPr lang="en-US"/>
-              <a:t>the closing line as the contract for the lecture</a:t>
-            </a:r>
-            <a:r>
-              <a:rPr lang="en-US" dirty="0"/>
-              <a:t>.</a:t>
-            </a:r>
-            <a:endParaRPr lang="en-US"/>
+              <a:t>Signpost. Tell students that everything in Part 1 is model definition — no fitting yet.</a:t>
+            </a:r>
           </a:p>
         </p:txBody>
       </p:sp>
@@ -1222,7 +1112,7 @@
           <a:p>
             <a:r>
               <a:rPr lang="en-US"/>
-              <a:t>Signpost. Tell students that everything in Part 1 is model definition — no fitting yet.</a:t>
+              <a:t>Fix notation before any math. Introduce the Default/balance example here — it returns on the odds, loss, and worked-example slides. Linear regression is not wrong so much as mismatched.</a:t>
             </a:r>
           </a:p>
         </p:txBody>
@@ -1268,8 +1158,28 @@
           <a:lstStyle/>
           <a:p>
             <a:r>
+              <a:rPr lang="en-US" dirty="0"/>
+              <a:t>Stress that z is a latent score on the whole real line. The sigmoid is the smooth monotone squashing function that makes the log-odds linear. </a:t>
+            </a:r>
+            <a:r>
               <a:rPr lang="en-US"/>
-              <a:t>Fix notation before any math. Introduce the Default/balance example here — it returns on the odds, loss, and worked-example slides. Linear regression is not wrong so much as mismatched.</a:t>
+              <a:t>Close by previewing </a:t>
+            </a:r>
+            <a:r>
+              <a:rPr lang="en-US" dirty="0"/>
+              <a:t>the </a:t>
+            </a:r>
+            <a:r>
+              <a:rPr lang="en-US"/>
+              <a:t>logit as </a:t>
+            </a:r>
+            <a:r>
+              <a:rPr lang="en-US" dirty="0"/>
+              <a:t>the </a:t>
+            </a:r>
+            <a:r>
+              <a:rPr lang="en-US"/>
+              <a:t>inverse.</a:t>
             </a:r>
           </a:p>
         </p:txBody>
@@ -1362,12 +1272,8 @@
           <a:lstStyle/>
           <a:p>
             <a:r>
-              <a:rPr lang="en-US" dirty="0"/>
-              <a:t>Stress that z is a latent score on the whole real line. The sigmoid is the smooth monotone squashing function that makes the log-odds linear. </a:t>
-            </a:r>
-            <a:r>
               <a:rPr lang="en-US"/>
-              <a:t>Close by previewing </a:t>
+              <a:t>Define odds concretely with </a:t>
             </a:r>
             <a:r>
               <a:rPr lang="en-US" dirty="0"/>
@@ -1375,7 +1281,7 @@
             </a:r>
             <a:r>
               <a:rPr lang="en-US"/>
-              <a:t>logit as </a:t>
+              <a:t>Default numbers before writing </a:t>
             </a:r>
             <a:r>
               <a:rPr lang="en-US" dirty="0"/>
@@ -1383,8 +1289,37 @@
             </a:r>
             <a:r>
               <a:rPr lang="en-US"/>
-              <a:t>inverse.</a:t>
-            </a:r>
+              <a:t>logit</a:t>
+            </a:r>
+            <a:r>
+              <a:rPr lang="en-US" dirty="0"/>
+              <a:t>. </a:t>
+            </a:r>
+            <a:r>
+              <a:rPr lang="en-US"/>
+              <a:t>The punchline: </a:t>
+            </a:r>
+            <a:r>
+              <a:rPr lang="en-US" dirty="0"/>
+              <a:t>the </a:t>
+            </a:r>
+            <a:r>
+              <a:rPr lang="en-US"/>
+              <a:t>model is linear, but </a:t>
+            </a:r>
+            <a:r>
+              <a:rPr lang="en-US" dirty="0"/>
+              <a:t>in log-odds, </a:t>
+            </a:r>
+            <a:r>
+              <a:rPr lang="en-US"/>
+              <a:t>not </a:t>
+            </a:r>
+            <a:r>
+              <a:rPr lang="en-US" dirty="0"/>
+              <a:t>probability.</a:t>
+            </a:r>
+            <a:endParaRPr lang="en-US"/>
           </a:p>
         </p:txBody>
       </p:sp>
@@ -1430,53 +1365,8 @@
           <a:p>
             <a:r>
               <a:rPr lang="en-US"/>
-              <a:t>Define odds concretely with </a:t>
-            </a:r>
-            <a:r>
-              <a:rPr lang="en-US" dirty="0"/>
-              <a:t>the </a:t>
-            </a:r>
-            <a:r>
-              <a:rPr lang="en-US"/>
-              <a:t>Default numbers before writing </a:t>
-            </a:r>
-            <a:r>
-              <a:rPr lang="en-US" dirty="0"/>
-              <a:t>the </a:t>
-            </a:r>
-            <a:r>
-              <a:rPr lang="en-US"/>
-              <a:t>logit</a:t>
-            </a:r>
-            <a:r>
-              <a:rPr lang="en-US" dirty="0"/>
-              <a:t>. </a:t>
-            </a:r>
-            <a:r>
-              <a:rPr lang="en-US"/>
-              <a:t>The punchline: </a:t>
-            </a:r>
-            <a:r>
-              <a:rPr lang="en-US" dirty="0"/>
-              <a:t>the </a:t>
-            </a:r>
-            <a:r>
-              <a:rPr lang="en-US"/>
-              <a:t>model is linear, but </a:t>
-            </a:r>
-            <a:r>
-              <a:rPr lang="en-US" dirty="0"/>
-              <a:t>in log-odds, </a:t>
-            </a:r>
-            <a:r>
-              <a:rPr lang="en-US"/>
-              <a:t>not </a:t>
-            </a:r>
-            <a:r>
-              <a:rPr lang="en-US" dirty="0"/>
-              <a:t>probability.</a:t>
-            </a:r>
-            <a:endParaRPr lang="en-US"/>
+              <a:t>This is the interpretability payoff and the most exam-relevant idea. Additive in log-odds, multiplicative in odds. Spend real time on the trap: odds ratios are constant, probability changes are not.</a:t>
+            </a:r>
           </a:p>
         </p:txBody>
       </p:sp>
@@ -1522,7 +1412,7 @@
           <a:p>
             <a:r>
               <a:rPr lang="en-US"/>
-              <a:t>This is the interpretability payoff and the most exam-relevant idea. Additive in log-odds, multiplicative in odds. Spend real time on the trap: odds ratios are constant, probability changes are not.</a:t>
+              <a:t>Signpost. The model is now fully specified; everything in Part 2 is estimation.</a:t>
             </a:r>
           </a:p>
         </p:txBody>
@@ -1568,9 +1458,34 @@
           <a:lstStyle/>
           <a:p>
             <a:r>
+              <a:rPr lang="en-US" dirty="0"/>
+              <a:t>The Bernoulli assumption is what earns us a likelihood — loss, optimization, </a:t>
+            </a:r>
+            <a:r>
               <a:rPr lang="en-US"/>
-              <a:t>Signpost. The model is now fully specified; everything in Part 2 is estimation.</a:t>
-            </a:r>
+              <a:t>and </a:t>
+            </a:r>
+            <a:r>
+              <a:rPr lang="en-US" dirty="0"/>
+              <a:t>inference</a:t>
+            </a:r>
+            <a:r>
+              <a:rPr lang="en-US"/>
+              <a:t> all follow </a:t>
+            </a:r>
+            <a:r>
+              <a:rPr lang="en-US" dirty="0"/>
+              <a:t>from this</a:t>
+            </a:r>
+            <a:r>
+              <a:rPr lang="en-US"/>
+              <a:t> one</a:t>
+            </a:r>
+            <a:r>
+              <a:rPr lang="en-US" dirty="0"/>
+              <a:t> line.</a:t>
+            </a:r>
+            <a:endParaRPr lang="en-US"/>
           </a:p>
         </p:txBody>
       </p:sp>
@@ -1735,7 +1650,7 @@
           <a:p>
             <a:fld id="{D1D1EADE-8E88-4C7C-8AC5-FB148DE4940E}" type="datetime1">
               <a:rPr lang="en-US" smtClean="0"/>
-              <a:t>9/23/2026</a:t>
+              <a:t>10/20/2026</a:t>
             </a:fld>
             <a:endParaRPr lang="en-US"/>
           </a:p>
@@ -1935,7 +1850,7 @@
           <a:p>
             <a:fld id="{EC3C8B9C-477D-492A-96AD-1FC2CC997A73}" type="datetime1">
               <a:rPr lang="en-US" smtClean="0"/>
-              <a:t>9/23/2026</a:t>
+              <a:t>10/20/2026</a:t>
             </a:fld>
             <a:endParaRPr lang="en-US"/>
           </a:p>
@@ -2145,7 +2060,7 @@
           <a:p>
             <a:fld id="{42D3AED5-E26D-4E29-B1B3-7847B6779594}" type="datetime1">
               <a:rPr lang="en-US" smtClean="0"/>
-              <a:t>9/23/2026</a:t>
+              <a:t>10/20/2026</a:t>
             </a:fld>
             <a:endParaRPr lang="en-US"/>
           </a:p>
@@ -2345,7 +2260,7 @@
           <a:p>
             <a:fld id="{157B6794-849E-4626-908B-D15793550EFB}" type="datetime1">
               <a:rPr lang="en-US" smtClean="0"/>
-              <a:t>9/23/2026</a:t>
+              <a:t>10/20/2026</a:t>
             </a:fld>
             <a:endParaRPr lang="en-US"/>
           </a:p>
@@ -2621,7 +2536,7 @@
           <a:p>
             <a:fld id="{63DB64E7-5594-42A3-ADBF-E95A7ACEAD64}" type="datetime1">
               <a:rPr lang="en-US" smtClean="0"/>
-              <a:t>9/23/2026</a:t>
+              <a:t>10/20/2026</a:t>
             </a:fld>
             <a:endParaRPr lang="en-US"/>
           </a:p>
@@ -2894,7 +2809,7 @@
           <a:p>
             <a:fld id="{18462B0B-D248-4FFB-8695-AD7FA4B1284A}" type="datetime1">
               <a:rPr lang="en-US" smtClean="0"/>
-              <a:t>9/23/2026</a:t>
+              <a:t>10/20/2026</a:t>
             </a:fld>
             <a:endParaRPr lang="en-US"/>
           </a:p>
@@ -3317,7 +3232,7 @@
           <a:p>
             <a:fld id="{D0378EFB-9159-4510-B73F-4F0409ADE937}" type="datetime1">
               <a:rPr lang="en-US" smtClean="0"/>
-              <a:t>9/23/2026</a:t>
+              <a:t>10/20/2026</a:t>
             </a:fld>
             <a:endParaRPr lang="en-US"/>
           </a:p>
@@ -3459,7 +3374,7 @@
           <a:p>
             <a:fld id="{89BC9412-2452-4BED-A324-9D8C115361AD}" type="datetime1">
               <a:rPr lang="en-US" smtClean="0"/>
-              <a:t>9/23/2026</a:t>
+              <a:t>10/20/2026</a:t>
             </a:fld>
             <a:endParaRPr lang="en-US"/>
           </a:p>
@@ -3572,7 +3487,7 @@
           <a:p>
             <a:fld id="{F5318F62-D251-40E8-A23C-F4CFE9FEAB41}" type="datetime1">
               <a:rPr lang="en-US" smtClean="0"/>
-              <a:t>9/23/2026</a:t>
+              <a:t>10/20/2026</a:t>
             </a:fld>
             <a:endParaRPr lang="en-US"/>
           </a:p>
@@ -3885,7 +3800,7 @@
           <a:p>
             <a:fld id="{44F76144-149E-4874-93A5-554A0357CF82}" type="datetime1">
               <a:rPr lang="en-US" smtClean="0"/>
-              <a:t>9/23/2026</a:t>
+              <a:t>10/20/2026</a:t>
             </a:fld>
             <a:endParaRPr lang="en-US"/>
           </a:p>
@@ -4178,7 +4093,7 @@
           <a:p>
             <a:fld id="{50BA65D8-0540-4835-AE5C-25D29DBA01BE}" type="datetime1">
               <a:rPr lang="en-US" smtClean="0"/>
-              <a:t>9/23/2026</a:t>
+              <a:t>10/20/2026</a:t>
             </a:fld>
             <a:endParaRPr lang="en-US"/>
           </a:p>
@@ -4418,7 +4333,7 @@
           <a:p>
             <a:fld id="{E31BA835-12AC-4E8F-955A-EA3F4DE2791F}" type="datetime1">
               <a:rPr lang="en-US" smtClean="0"/>
-              <a:t>9/23/2026</a:t>
+              <a:t>10/20/2026</a:t>
             </a:fld>
             <a:endParaRPr lang="en-US"/>
           </a:p>
@@ -5383,228 +5298,6 @@
         <p:spPr>
           <a:xfrm>
             <a:off x="1981200" y="1029062"/>
-            <a:ext cx="9500000" cy="646331"/>
-          </a:xfrm>
-          <a:prstGeom prst="rect">
-            <a:avLst/>
-          </a:prstGeom>
-          <a:noFill/>
-        </p:spPr>
-        <p:txBody>
-          <a:bodyPr wrap="none">
-            <a:spAutoFit/>
-          </a:bodyPr>
-          <a:lstStyle/>
-          <a:p>
-            <a:pPr>
-              <a:defRPr sz="3600" b="1"/>
-            </a:pPr>
-            <a:r>
-              <a:rPr lang="en-US" sz="3600" b="1" cap="all">
-                <a:solidFill>
-                  <a:srgbClr val="13131A"/>
-                </a:solidFill>
-                <a:latin typeface="+mj-lt"/>
-              </a:rPr>
-              <a:t>The Bernoulli Model</a:t>
-            </a:r>
-          </a:p>
-        </p:txBody>
-      </p:sp>
-      <p:sp>
-        <p:nvSpPr>
-          <p:cNvPr id="4" name="TextBox 3"/>
-          <p:cNvSpPr txBox="1"/>
-          <p:nvPr/>
-        </p:nvSpPr>
-        <p:spPr>
-          <a:xfrm>
-            <a:off x="1981200" y="1950000"/>
-            <a:ext cx="8229600" cy="2395528"/>
-          </a:xfrm>
-          <a:prstGeom prst="rect">
-            <a:avLst/>
-          </a:prstGeom>
-          <a:noFill/>
-        </p:spPr>
-        <p:txBody>
-          <a:bodyPr wrap="square">
-            <a:spAutoFit/>
-          </a:bodyPr>
-          <a:lstStyle/>
-          <a:p>
-            <a:pPr>
-              <a:spcBef>
-                <a:spcPts val="500"/>
-              </a:spcBef>
-              <a:spcAft>
-                <a:spcPts val="500"/>
-              </a:spcAft>
-            </a:pPr>
-            <a:r>
-              <a:rPr lang="en-US" sz="1500" dirty="0">
-                <a:solidFill>
-                  <a:srgbClr val="13131A"/>
-                </a:solidFill>
-              </a:rPr>
-              <a:t>Explicitly model the data-generating process:</a:t>
-            </a:r>
-            <a:endParaRPr lang="en-US" sz="1500" dirty="0"/>
-          </a:p>
-          <a:p>
-            <a:pPr>
-              <a:spcBef>
-                <a:spcPts val="500"/>
-              </a:spcBef>
-              <a:spcAft>
-                <a:spcPts val="500"/>
-              </a:spcAft>
-            </a:pPr>
-            <a:r>
-              <a:rPr lang="en-US" sz="1700" dirty="0">
-                <a:solidFill>
-                  <a:srgbClr val="13131A"/>
-                </a:solidFill>
-                <a:latin typeface="Cambria Math"/>
-              </a:rPr>
-              <a:t>y | x  ~  Bernoulli(p),    p = σ(</a:t>
-            </a:r>
-            <a:r>
-              <a:rPr lang="en-US" sz="1700" dirty="0" err="1">
-                <a:solidFill>
-                  <a:srgbClr val="13131A"/>
-                </a:solidFill>
-                <a:latin typeface="Cambria Math"/>
-              </a:rPr>
-              <a:t>wᵀx</a:t>
-            </a:r>
-            <a:r>
-              <a:rPr lang="en-US" sz="1700" dirty="0">
-                <a:solidFill>
-                  <a:srgbClr val="13131A"/>
-                </a:solidFill>
-                <a:latin typeface="Cambria Math"/>
-              </a:rPr>
-              <a:t> + b)</a:t>
-            </a:r>
-            <a:endParaRPr lang="en-US" sz="1700" dirty="0"/>
-          </a:p>
-          <a:p>
-            <a:pPr>
-              <a:spcBef>
-                <a:spcPts val="500"/>
-              </a:spcBef>
-              <a:spcAft>
-                <a:spcPts val="500"/>
-              </a:spcAft>
-            </a:pPr>
-            <a:r>
-              <a:rPr lang="en-US" sz="1500" dirty="0">
-                <a:solidFill>
-                  <a:srgbClr val="13131A"/>
-                </a:solidFill>
-              </a:rPr>
-              <a:t>A Bernoulli random variable equals 1 with probability p and 0 with probability 1 − p — a single weighted coin flip. Each customer either defaults or does not; the model sets the bias of that coin.</a:t>
-            </a:r>
-            <a:endParaRPr lang="en-US" sz="1500" dirty="0"/>
-          </a:p>
-          <a:p>
-            <a:pPr>
-              <a:spcBef>
-                <a:spcPts val="500"/>
-              </a:spcBef>
-              <a:spcAft>
-                <a:spcPts val="500"/>
-              </a:spcAft>
-            </a:pPr>
-            <a:r>
-              <a:rPr lang="en-US" sz="1600" b="1" dirty="0">
-                <a:solidFill>
-                  <a:srgbClr val="13131A"/>
-                </a:solidFill>
-              </a:rPr>
-              <a:t>Why this choice</a:t>
-            </a:r>
-            <a:endParaRPr lang="en-US" sz="1600" dirty="0"/>
-          </a:p>
-          <a:p>
-            <a:pPr marL="285750" indent="-285750">
-              <a:spcBef>
-                <a:spcPts val="500"/>
-              </a:spcBef>
-              <a:spcAft>
-                <a:spcPts val="500"/>
-              </a:spcAft>
-              <a:buFont typeface="Arial" panose="020B0604020202020204" pitchFamily="34" charset="0"/>
-              <a:buChar char="•"/>
-            </a:pPr>
-            <a:r>
-              <a:rPr lang="en-US" sz="1500" dirty="0">
-                <a:solidFill>
-                  <a:srgbClr val="13131A"/>
-                </a:solidFill>
-              </a:rPr>
-              <a:t>It matches the binary nature of the data</a:t>
-            </a:r>
-            <a:endParaRPr lang="en-US" sz="1500" dirty="0"/>
-          </a:p>
-          <a:p>
-            <a:pPr marL="285750" indent="-285750">
-              <a:spcBef>
-                <a:spcPts val="500"/>
-              </a:spcBef>
-              <a:spcAft>
-                <a:spcPts val="500"/>
-              </a:spcAft>
-              <a:buFont typeface="Arial" panose="020B0604020202020204" pitchFamily="34" charset="0"/>
-              <a:buChar char="•"/>
-            </a:pPr>
-            <a:r>
-              <a:rPr lang="en-US" sz="1500" dirty="0">
-                <a:solidFill>
-                  <a:srgbClr val="13131A"/>
-                </a:solidFill>
-              </a:rPr>
-              <a:t>It gives a principled, likelihood-based</a:t>
-            </a:r>
-            <a:endParaRPr lang="en-US" sz="1500" dirty="0"/>
-          </a:p>
-        </p:txBody>
-      </p:sp>
-    </p:spTree>
-  </p:cSld>
-  <p:clrMapOvr>
-    <a:masterClrMapping/>
-  </p:clrMapOvr>
-</p:sld>
-</file>
-
-<file path=ppt/slides/slide11.xml><?xml version="1.0" encoding="utf-8"?>
-<p:sld xmlns:a="http://schemas.openxmlformats.org/drawingml/2006/main" xmlns:r="http://schemas.openxmlformats.org/officeDocument/2006/relationships" xmlns:p="http://schemas.openxmlformats.org/presentationml/2006/main">
-  <p:cSld>
-    <p:spTree>
-      <p:nvGrpSpPr>
-        <p:cNvPr id="1" name=""/>
-        <p:cNvGrpSpPr/>
-        <p:nvPr/>
-      </p:nvGrpSpPr>
-      <p:grpSpPr>
-        <a:xfrm>
-          <a:off x="0" y="0"/>
-          <a:ext cx="0" cy="0"/>
-          <a:chOff x="0" y="0"/>
-          <a:chExt cx="0" cy="0"/>
-        </a:xfrm>
-      </p:grpSpPr>
-      <p:sp>
-        <p:nvSpPr>
-          <p:cNvPr id="2" name="TextBox 1"/>
-          <p:cNvSpPr txBox="1"/>
-          <p:nvPr/>
-        </p:nvSpPr>
-        <p:spPr>
-          <a:xfrm>
-            <a:off x="1981200" y="1029062"/>
             <a:ext cx="8257197" cy="646331"/>
           </a:xfrm>
           <a:prstGeom prst="rect">
@@ -6140,7 +5833,7 @@
 </p:sld>
 </file>
 
-<file path=ppt/slides/slide12.xml><?xml version="1.0" encoding="utf-8"?>
+<file path=ppt/slides/slide11.xml><?xml version="1.0" encoding="utf-8"?>
 <p:sld xmlns:a="http://schemas.openxmlformats.org/drawingml/2006/main" xmlns:r="http://schemas.openxmlformats.org/officeDocument/2006/relationships" xmlns:p="http://schemas.openxmlformats.org/presentationml/2006/main">
   <p:cSld>
     <p:spTree>
@@ -6385,6 +6078,69 @@
 </p:sld>
 </file>
 
+<file path=ppt/slides/slide12.xml><?xml version="1.0" encoding="utf-8"?>
+<p:sld xmlns:a="http://schemas.openxmlformats.org/drawingml/2006/main" xmlns:r="http://schemas.openxmlformats.org/officeDocument/2006/relationships" xmlns:p="http://schemas.openxmlformats.org/presentationml/2006/main">
+  <p:cSld>
+    <p:spTree>
+      <p:nvGrpSpPr>
+        <p:cNvPr id="1" name=""/>
+        <p:cNvGrpSpPr/>
+        <p:nvPr/>
+      </p:nvGrpSpPr>
+      <p:grpSpPr>
+        <a:xfrm>
+          <a:off x="0" y="0"/>
+          <a:ext cx="0" cy="0"/>
+          <a:chOff x="0" y="0"/>
+          <a:chExt cx="0" cy="0"/>
+        </a:xfrm>
+      </p:grpSpPr>
+      <p:sp>
+        <p:nvSpPr>
+          <p:cNvPr id="2" name="Title 1">
+            <a:extLst>
+              <a:ext uri="{FF2B5EF4-FFF2-40B4-BE49-F238E27FC236}">
+                <a16:creationId xmlns:a16="http://schemas.microsoft.com/office/drawing/2014/main" id="{7513127E-D6DF-382F-49A1-1891ADEA51A0}"/>
+              </a:ext>
+            </a:extLst>
+          </p:cNvPr>
+          <p:cNvSpPr>
+            <a:spLocks noGrp="1"/>
+          </p:cNvSpPr>
+          <p:nvPr>
+            <p:ph type="title"/>
+          </p:nvPr>
+        </p:nvSpPr>
+        <p:spPr>
+          <a:xfrm>
+            <a:off x="3169515" y="2926080"/>
+            <a:ext cx="10691265" cy="1307592"/>
+          </a:xfrm>
+        </p:spPr>
+        <p:txBody>
+          <a:bodyPr/>
+          <a:lstStyle/>
+          <a:p>
+            <a:r>
+              <a:rPr lang="en-US" dirty="0"/>
+              <a:t>Optimization Setup</a:t>
+            </a:r>
+          </a:p>
+        </p:txBody>
+      </p:sp>
+    </p:spTree>
+    <p:extLst>
+      <p:ext uri="{BB962C8B-B14F-4D97-AF65-F5344CB8AC3E}">
+        <p14:creationId xmlns:p14="http://schemas.microsoft.com/office/powerpoint/2010/main" val="1748380872"/>
+      </p:ext>
+    </p:extLst>
+  </p:cSld>
+  <p:clrMapOvr>
+    <a:masterClrMapping/>
+  </p:clrMapOvr>
+</p:sld>
+</file>
+
 <file path=ppt/slides/slide13.xml><?xml version="1.0" encoding="utf-8"?>
 <p:sld xmlns:a="http://schemas.openxmlformats.org/drawingml/2006/main" xmlns:r="http://schemas.openxmlformats.org/officeDocument/2006/relationships" xmlns:p="http://schemas.openxmlformats.org/presentationml/2006/main">
   <p:cSld>
@@ -6404,43 +6160,266 @@
       </p:grpSpPr>
       <p:sp>
         <p:nvSpPr>
-          <p:cNvPr id="2" name="Title 1">
-            <a:extLst>
-              <a:ext uri="{FF2B5EF4-FFF2-40B4-BE49-F238E27FC236}">
-                <a16:creationId xmlns:a16="http://schemas.microsoft.com/office/drawing/2014/main" id="{7513127E-D6DF-382F-49A1-1891ADEA51A0}"/>
-              </a:ext>
-            </a:extLst>
-          </p:cNvPr>
-          <p:cNvSpPr>
-            <a:spLocks noGrp="1"/>
-          </p:cNvSpPr>
-          <p:nvPr>
-            <p:ph type="title"/>
-          </p:nvPr>
+          <p:cNvPr id="2" name="TextBox 1"/>
+          <p:cNvSpPr txBox="1"/>
+          <p:nvPr/>
         </p:nvSpPr>
         <p:spPr>
           <a:xfrm>
-            <a:off x="3169515" y="2926080"/>
-            <a:ext cx="10691265" cy="1307592"/>
+            <a:off x="1981200" y="1029062"/>
+            <a:ext cx="7842147" cy="646331"/>
           </a:xfrm>
+          <a:prstGeom prst="rect">
+            <a:avLst/>
+          </a:prstGeom>
+          <a:noFill/>
         </p:spPr>
         <p:txBody>
-          <a:bodyPr/>
+          <a:bodyPr wrap="none">
+            <a:spAutoFit/>
+          </a:bodyPr>
           <a:lstStyle/>
           <a:p>
-            <a:r>
-              <a:rPr lang="en-US" dirty="0"/>
-              <a:t>Optimization Setup</a:t>
-            </a:r>
+            <a:pPr>
+              <a:defRPr sz="3600" b="1"/>
+            </a:pPr>
+            <a:r>
+              <a:rPr lang="en-US" sz="3600" b="1" cap="all">
+                <a:solidFill>
+                  <a:srgbClr val="13131A"/>
+                </a:solidFill>
+                <a:latin typeface="+mj-lt"/>
+              </a:rPr>
+              <a:t>Optimization II: Gradient Descent</a:t>
+            </a:r>
+          </a:p>
+        </p:txBody>
+      </p:sp>
+      <p:sp>
+        <p:nvSpPr>
+          <p:cNvPr id="4" name="TextBox 3"/>
+          <p:cNvSpPr txBox="1"/>
+          <p:nvPr/>
+        </p:nvSpPr>
+        <p:spPr>
+          <a:xfrm>
+            <a:off x="1981200" y="1950000"/>
+            <a:ext cx="8229600" cy="4262705"/>
+          </a:xfrm>
+          <a:prstGeom prst="rect">
+            <a:avLst/>
+          </a:prstGeom>
+          <a:noFill/>
+        </p:spPr>
+        <p:txBody>
+          <a:bodyPr wrap="square">
+            <a:spAutoFit/>
+          </a:bodyPr>
+          <a:lstStyle/>
+          <a:p>
+            <a:pPr>
+              <a:spcBef>
+                <a:spcPts val="500"/>
+              </a:spcBef>
+              <a:spcAft>
+                <a:spcPts val="500"/>
+              </a:spcAft>
+            </a:pPr>
+            <a:r>
+              <a:rPr lang="en-US" b="1" dirty="0">
+                <a:solidFill>
+                  <a:srgbClr val="13131A"/>
+                </a:solidFill>
+              </a:rPr>
+              <a:t>Gradient of the loss with respect to the weights:</a:t>
+            </a:r>
+            <a:endParaRPr lang="en-US" dirty="0"/>
+          </a:p>
+          <a:p>
+            <a:pPr>
+              <a:spcBef>
+                <a:spcPts val="500"/>
+              </a:spcBef>
+              <a:spcAft>
+                <a:spcPts val="500"/>
+              </a:spcAft>
+            </a:pPr>
+            <a:r>
+              <a:rPr lang="en-US" sz="2000" dirty="0">
+                <a:solidFill>
+                  <a:srgbClr val="13131A"/>
+                </a:solidFill>
+                <a:latin typeface="Cambria Math"/>
+              </a:rPr>
+              <a:t>∂ℒ/∂w = Σᵢ (pᵢ − yᵢ) xᵢ</a:t>
+            </a:r>
+            <a:endParaRPr lang="en-US" sz="2000" dirty="0"/>
+          </a:p>
+          <a:p>
+            <a:pPr>
+              <a:spcBef>
+                <a:spcPts val="500"/>
+              </a:spcBef>
+              <a:spcAft>
+                <a:spcPts val="500"/>
+              </a:spcAft>
+            </a:pPr>
+            <a:r>
+              <a:rPr lang="en-US" dirty="0">
+                <a:solidFill>
+                  <a:srgbClr val="13131A"/>
+                </a:solidFill>
+              </a:rPr>
+              <a:t>Update rule: step downhill, w ← w − η · ∂ℒ/∂w, where η is the learning rate.</a:t>
+            </a:r>
+            <a:endParaRPr lang="en-US" dirty="0"/>
+          </a:p>
+          <a:p>
+            <a:pPr>
+              <a:spcBef>
+                <a:spcPts val="500"/>
+              </a:spcBef>
+              <a:spcAft>
+                <a:spcPts val="500"/>
+              </a:spcAft>
+            </a:pPr>
+            <a:r>
+              <a:rPr lang="en-US" sz="2000" b="1" dirty="0">
+                <a:solidFill>
+                  <a:srgbClr val="13131A"/>
+                </a:solidFill>
+              </a:rPr>
+              <a:t>A direct parallel to linear regression</a:t>
+            </a:r>
+            <a:endParaRPr lang="en-US" sz="2000" dirty="0"/>
+          </a:p>
+          <a:p>
+            <a:pPr marL="285750" indent="-285750">
+              <a:spcBef>
+                <a:spcPts val="500"/>
+              </a:spcBef>
+              <a:spcAft>
+                <a:spcPts val="500"/>
+              </a:spcAft>
+              <a:buFont typeface="Arial" panose="020B0604020202020204" pitchFamily="34" charset="0"/>
+              <a:buChar char="•"/>
+            </a:pPr>
+            <a:r>
+              <a:rPr lang="en-US" dirty="0">
+                <a:solidFill>
+                  <a:srgbClr val="13131A"/>
+                </a:solidFill>
+              </a:rPr>
+              <a:t>Linear regression: updates use residuals (ŷ − y)</a:t>
+            </a:r>
+            <a:endParaRPr lang="en-US" dirty="0"/>
+          </a:p>
+          <a:p>
+            <a:pPr marL="285750" indent="-285750">
+              <a:spcBef>
+                <a:spcPts val="500"/>
+              </a:spcBef>
+              <a:spcAft>
+                <a:spcPts val="500"/>
+              </a:spcAft>
+              <a:buFont typeface="Arial" panose="020B0604020202020204" pitchFamily="34" charset="0"/>
+              <a:buChar char="•"/>
+            </a:pPr>
+            <a:r>
+              <a:rPr lang="en-US" dirty="0">
+                <a:solidFill>
+                  <a:srgbClr val="13131A"/>
+                </a:solidFill>
+              </a:rPr>
+              <a:t>Logistic regression: updates use probabilistic errors (p − y)</a:t>
+            </a:r>
+            <a:endParaRPr lang="en-US" dirty="0"/>
+          </a:p>
+          <a:p>
+            <a:pPr>
+              <a:spcBef>
+                <a:spcPts val="500"/>
+              </a:spcBef>
+              <a:spcAft>
+                <a:spcPts val="500"/>
+              </a:spcAft>
+            </a:pPr>
+            <a:r>
+              <a:rPr lang="en-US" sz="2000" b="1" dirty="0">
+                <a:solidFill>
+                  <a:srgbClr val="13131A"/>
+                </a:solidFill>
+              </a:rPr>
+              <a:t>Interpretation</a:t>
+            </a:r>
+            <a:endParaRPr lang="en-US" sz="2000" dirty="0"/>
+          </a:p>
+          <a:p>
+            <a:pPr marL="285750" indent="-285750">
+              <a:spcBef>
+                <a:spcPts val="500"/>
+              </a:spcBef>
+              <a:spcAft>
+                <a:spcPts val="500"/>
+              </a:spcAft>
+              <a:buFont typeface="Arial" panose="020B0604020202020204" pitchFamily="34" charset="0"/>
+              <a:buChar char="•"/>
+            </a:pPr>
+            <a:r>
+              <a:rPr lang="en-US" dirty="0">
+                <a:solidFill>
+                  <a:srgbClr val="13131A"/>
+                </a:solidFill>
+              </a:rPr>
+              <a:t>p &gt; y: the gradient pushes the prediction down toward 0</a:t>
+            </a:r>
+            <a:endParaRPr lang="en-US" dirty="0"/>
+          </a:p>
+          <a:p>
+            <a:pPr marL="285750" indent="-285750">
+              <a:spcBef>
+                <a:spcPts val="500"/>
+              </a:spcBef>
+              <a:spcAft>
+                <a:spcPts val="500"/>
+              </a:spcAft>
+              <a:buFont typeface="Arial" panose="020B0604020202020204" pitchFamily="34" charset="0"/>
+              <a:buChar char="•"/>
+            </a:pPr>
+            <a:r>
+              <a:rPr lang="en-US" dirty="0">
+                <a:solidFill>
+                  <a:srgbClr val="13131A"/>
+                </a:solidFill>
+              </a:rPr>
+              <a:t>p &lt; y: the gradient pulls the prediction up toward 1</a:t>
+            </a:r>
+            <a:endParaRPr lang="en-US" dirty="0"/>
+          </a:p>
+          <a:p>
+            <a:pPr marL="285750" indent="-285750">
+              <a:spcBef>
+                <a:spcPts val="500"/>
+              </a:spcBef>
+              <a:spcAft>
+                <a:spcPts val="500"/>
+              </a:spcAft>
+              <a:buFont typeface="Arial" panose="020B0604020202020204" pitchFamily="34" charset="0"/>
+              <a:buChar char="•"/>
+            </a:pPr>
+            <a:r>
+              <a:rPr lang="en-US" dirty="0">
+                <a:solidFill>
+                  <a:srgbClr val="13131A"/>
+                </a:solidFill>
+              </a:rPr>
+              <a:t>p ≈ y: the signal is small — that observation is already explained</a:t>
+            </a:r>
+            <a:endParaRPr lang="en-US" dirty="0"/>
           </a:p>
         </p:txBody>
       </p:sp>
     </p:spTree>
-    <p:extLst>
-      <p:ext uri="{BB962C8B-B14F-4D97-AF65-F5344CB8AC3E}">
-        <p14:creationId xmlns:p14="http://schemas.microsoft.com/office/powerpoint/2010/main" val="1748380872"/>
-      </p:ext>
-    </p:extLst>
   </p:cSld>
   <p:clrMapOvr>
     <a:masterClrMapping/>
@@ -6474,7 +6453,7 @@
         <p:spPr>
           <a:xfrm>
             <a:off x="1981200" y="1029062"/>
-            <a:ext cx="7842147" cy="646331"/>
+            <a:ext cx="9500000" cy="646331"/>
           </a:xfrm>
           <a:prstGeom prst="rect">
             <a:avLst/>
@@ -6488,16 +6467,16 @@
           <a:lstStyle/>
           <a:p>
             <a:pPr>
-              <a:defRPr sz="3600" b="1"/>
-            </a:pPr>
-            <a:r>
-              <a:rPr lang="en-US" sz="3600" b="1" cap="all">
+              <a:defRPr sz="3200" b="1"/>
+            </a:pPr>
+            <a:r>
+              <a:rPr lang="en-US" sz="3200" b="1" cap="all">
                 <a:solidFill>
                   <a:srgbClr val="13131A"/>
                 </a:solidFill>
                 <a:latin typeface="+mj-lt"/>
               </a:rPr>
-              <a:t>Optimization II: Gradient Descent</a:t>
+              <a:t>Part 3 — Using the Model</a:t>
             </a:r>
           </a:p>
         </p:txBody>
@@ -6510,8 +6489,8 @@
         </p:nvSpPr>
         <p:spPr>
           <a:xfrm>
-            <a:off x="1981200" y="1950000"/>
-            <a:ext cx="8229600" cy="4262705"/>
+            <a:off x="1981200" y="2100000"/>
+            <a:ext cx="8229600" cy="4083169"/>
           </a:xfrm>
           <a:prstGeom prst="rect">
             <a:avLst/>
@@ -6533,14 +6512,14 @@
               </a:spcAft>
             </a:pPr>
             <a:r>
-              <a:rPr lang="en-US" b="1" dirty="0">
-                <a:solidFill>
-                  <a:srgbClr val="13131A"/>
-                </a:solidFill>
-              </a:rPr>
-              <a:t>Gradient of the loss with respect to the weights:</a:t>
-            </a:r>
-            <a:endParaRPr lang="en-US" dirty="0"/>
+              <a:rPr lang="en-US" sz="1800" b="1">
+                <a:solidFill>
+                  <a:srgbClr val="13131A"/>
+                </a:solidFill>
+              </a:rPr>
+              <a:t>From a fitted probability to a decision.</a:t>
+            </a:r>
+            <a:endParaRPr lang="en-US" sz="1800"/>
           </a:p>
           <a:p>
             <a:pPr>
@@ -6552,15 +6531,14 @@
               </a:spcAft>
             </a:pPr>
             <a:r>
-              <a:rPr lang="en-US" sz="2000" dirty="0">
-                <a:solidFill>
-                  <a:srgbClr val="13131A"/>
-                </a:solidFill>
-                <a:latin typeface="Cambria Math"/>
-              </a:rPr>
-              <a:t>∂ℒ/∂w = Σᵢ (pᵢ − yᵢ) xᵢ</a:t>
-            </a:r>
-            <a:endParaRPr lang="en-US" sz="2000" dirty="0"/>
+              <a:rPr lang="en-US" sz="1500">
+                <a:solidFill>
+                  <a:srgbClr val="13131A"/>
+                </a:solidFill>
+              </a:rPr>
+              <a:t>•  How does a probability become a predicted class?</a:t>
+            </a:r>
+            <a:endParaRPr lang="en-US" sz="1500"/>
           </a:p>
           <a:p>
             <a:pPr>
@@ -6572,14 +6550,14 @@
               </a:spcAft>
             </a:pPr>
             <a:r>
-              <a:rPr lang="en-US" dirty="0">
-                <a:solidFill>
-                  <a:srgbClr val="13131A"/>
-                </a:solidFill>
-              </a:rPr>
-              <a:t>Update rule: step downhill, w ← w − η · ∂ℒ/∂w, where η is the learning rate.</a:t>
-            </a:r>
-            <a:endParaRPr lang="en-US" dirty="0"/>
+              <a:rPr lang="en-US" sz="1500">
+                <a:solidFill>
+                  <a:srgbClr val="13131A"/>
+                </a:solidFill>
+              </a:rPr>
+              <a:t>•  Who decides the threshold, and on what grounds?</a:t>
+            </a:r>
+            <a:endParaRPr lang="en-US" sz="1500"/>
           </a:p>
           <a:p>
             <a:pPr>
@@ -6591,138 +6569,14 @@
               </a:spcAft>
             </a:pPr>
             <a:r>
-              <a:rPr lang="en-US" sz="2000" b="1" dirty="0">
-                <a:solidFill>
-                  <a:srgbClr val="13131A"/>
-                </a:solidFill>
-              </a:rPr>
-              <a:t>A direct parallel to linear regression</a:t>
-            </a:r>
-            <a:endParaRPr lang="en-US" sz="2000" dirty="0"/>
-          </a:p>
-          <a:p>
-            <a:pPr marL="285750" indent="-285750">
-              <a:spcBef>
-                <a:spcPts val="500"/>
-              </a:spcBef>
-              <a:spcAft>
-                <a:spcPts val="500"/>
-              </a:spcAft>
-              <a:buFont typeface="Arial" panose="020B0604020202020204" pitchFamily="34" charset="0"/>
-              <a:buChar char="•"/>
-            </a:pPr>
-            <a:r>
-              <a:rPr lang="en-US" dirty="0">
-                <a:solidFill>
-                  <a:srgbClr val="13131A"/>
-                </a:solidFill>
-              </a:rPr>
-              <a:t>Linear regression: updates use residuals (ŷ − y)</a:t>
-            </a:r>
-            <a:endParaRPr lang="en-US" dirty="0"/>
-          </a:p>
-          <a:p>
-            <a:pPr marL="285750" indent="-285750">
-              <a:spcBef>
-                <a:spcPts val="500"/>
-              </a:spcBef>
-              <a:spcAft>
-                <a:spcPts val="500"/>
-              </a:spcAft>
-              <a:buFont typeface="Arial" panose="020B0604020202020204" pitchFamily="34" charset="0"/>
-              <a:buChar char="•"/>
-            </a:pPr>
-            <a:r>
-              <a:rPr lang="en-US" dirty="0">
-                <a:solidFill>
-                  <a:srgbClr val="13131A"/>
-                </a:solidFill>
-              </a:rPr>
-              <a:t>Logistic regression: updates use probabilistic errors (p − y)</a:t>
-            </a:r>
-            <a:endParaRPr lang="en-US" dirty="0"/>
-          </a:p>
-          <a:p>
-            <a:pPr>
-              <a:spcBef>
-                <a:spcPts val="500"/>
-              </a:spcBef>
-              <a:spcAft>
-                <a:spcPts val="500"/>
-              </a:spcAft>
-            </a:pPr>
-            <a:r>
-              <a:rPr lang="en-US" sz="2000" b="1" dirty="0">
-                <a:solidFill>
-                  <a:srgbClr val="13131A"/>
-                </a:solidFill>
-              </a:rPr>
-              <a:t>Interpretation</a:t>
-            </a:r>
-            <a:endParaRPr lang="en-US" sz="2000" dirty="0"/>
-          </a:p>
-          <a:p>
-            <a:pPr marL="285750" indent="-285750">
-              <a:spcBef>
-                <a:spcPts val="500"/>
-              </a:spcBef>
-              <a:spcAft>
-                <a:spcPts val="500"/>
-              </a:spcAft>
-              <a:buFont typeface="Arial" panose="020B0604020202020204" pitchFamily="34" charset="0"/>
-              <a:buChar char="•"/>
-            </a:pPr>
-            <a:r>
-              <a:rPr lang="en-US" dirty="0">
-                <a:solidFill>
-                  <a:srgbClr val="13131A"/>
-                </a:solidFill>
-              </a:rPr>
-              <a:t>p &gt; y: the gradient pushes the prediction down toward 0</a:t>
-            </a:r>
-            <a:endParaRPr lang="en-US" dirty="0"/>
-          </a:p>
-          <a:p>
-            <a:pPr marL="285750" indent="-285750">
-              <a:spcBef>
-                <a:spcPts val="500"/>
-              </a:spcBef>
-              <a:spcAft>
-                <a:spcPts val="500"/>
-              </a:spcAft>
-              <a:buFont typeface="Arial" panose="020B0604020202020204" pitchFamily="34" charset="0"/>
-              <a:buChar char="•"/>
-            </a:pPr>
-            <a:r>
-              <a:rPr lang="en-US" dirty="0">
-                <a:solidFill>
-                  <a:srgbClr val="13131A"/>
-                </a:solidFill>
-              </a:rPr>
-              <a:t>p &lt; y: the gradient pulls the prediction up toward 1</a:t>
-            </a:r>
-            <a:endParaRPr lang="en-US" dirty="0"/>
-          </a:p>
-          <a:p>
-            <a:pPr marL="285750" indent="-285750">
-              <a:spcBef>
-                <a:spcPts val="500"/>
-              </a:spcBef>
-              <a:spcAft>
-                <a:spcPts val="500"/>
-              </a:spcAft>
-              <a:buFont typeface="Arial" panose="020B0604020202020204" pitchFamily="34" charset="0"/>
-              <a:buChar char="•"/>
-            </a:pPr>
-            <a:r>
-              <a:rPr lang="en-US" dirty="0">
-                <a:solidFill>
-                  <a:srgbClr val="13131A"/>
-                </a:solidFill>
-              </a:rPr>
-              <a:t>p ≈ y: the signal is small — that observation is already explained</a:t>
-            </a:r>
-            <a:endParaRPr lang="en-US" dirty="0"/>
+              <a:rPr lang="en-US" sz="1500">
+                <a:solidFill>
+                  <a:srgbClr val="13131A"/>
+                </a:solidFill>
+              </a:rPr>
+              <a:t>•  Can you run the whole pipeline yourself?</a:t>
+            </a:r>
+            <a:endParaRPr lang="en-US" sz="1500"/>
           </a:p>
         </p:txBody>
       </p:sp>
@@ -6760,7 +6614,7 @@
         <p:spPr>
           <a:xfrm>
             <a:off x="1981200" y="1029062"/>
-            <a:ext cx="9500000" cy="646331"/>
+            <a:ext cx="7888378" cy="646331"/>
           </a:xfrm>
           <a:prstGeom prst="rect">
             <a:avLst/>
@@ -6774,16 +6628,16 @@
           <a:lstStyle/>
           <a:p>
             <a:pPr>
-              <a:defRPr sz="3200" b="1"/>
-            </a:pPr>
-            <a:r>
-              <a:rPr lang="en-US" sz="3200" b="1" cap="all">
+              <a:defRPr sz="3600" b="1"/>
+            </a:pPr>
+            <a:r>
+              <a:rPr lang="en-US" sz="3600" b="1" cap="all">
                 <a:solidFill>
                   <a:srgbClr val="13131A"/>
                 </a:solidFill>
                 <a:latin typeface="+mj-lt"/>
               </a:rPr>
-              <a:t>Part 3 — Using the Model</a:t>
+              <a:t>Classification: The Decision Rule</a:t>
             </a:r>
           </a:p>
         </p:txBody>
@@ -6796,8 +6650,8 @@
         </p:nvSpPr>
         <p:spPr>
           <a:xfrm>
-            <a:off x="1981200" y="2100000"/>
-            <a:ext cx="8229600" cy="4083169"/>
+            <a:off x="1981200" y="1950000"/>
+            <a:ext cx="8229600" cy="3416320"/>
           </a:xfrm>
           <a:prstGeom prst="rect">
             <a:avLst/>
@@ -6819,14 +6673,14 @@
               </a:spcAft>
             </a:pPr>
             <a:r>
-              <a:rPr lang="en-US" sz="1800" b="1">
-                <a:solidFill>
-                  <a:srgbClr val="13131A"/>
-                </a:solidFill>
-              </a:rPr>
-              <a:t>From a fitted probability to a decision.</a:t>
-            </a:r>
-            <a:endParaRPr lang="en-US" sz="1800"/>
+              <a:rPr lang="en-US" dirty="0">
+                <a:solidFill>
+                  <a:srgbClr val="13131A"/>
+                </a:solidFill>
+              </a:rPr>
+              <a:t>Logistic regression outputs probabilities. Classification needs one more ingredient — a decision threshold τ:</a:t>
+            </a:r>
+            <a:endParaRPr lang="en-US" dirty="0"/>
           </a:p>
           <a:p>
             <a:pPr>
@@ -6838,14 +6692,15 @@
               </a:spcAft>
             </a:pPr>
             <a:r>
-              <a:rPr lang="en-US" sz="1500">
-                <a:solidFill>
-                  <a:srgbClr val="13131A"/>
-                </a:solidFill>
-              </a:rPr>
-              <a:t>•  How does a probability become a predicted class?</a:t>
-            </a:r>
-            <a:endParaRPr lang="en-US" sz="1500"/>
+              <a:rPr lang="en-US" sz="2000" dirty="0">
+                <a:solidFill>
+                  <a:srgbClr val="13131A"/>
+                </a:solidFill>
+                <a:latin typeface="Cambria Math"/>
+              </a:rPr>
+              <a:t>ŷ = 1 if P(y = 1 | x) ≥ τ,   otherwise ŷ = 0</a:t>
+            </a:r>
+            <a:endParaRPr lang="en-US" sz="2000" dirty="0"/>
           </a:p>
           <a:p>
             <a:pPr>
@@ -6857,14 +6712,14 @@
               </a:spcAft>
             </a:pPr>
             <a:r>
-              <a:rPr lang="en-US" sz="1500">
-                <a:solidFill>
-                  <a:srgbClr val="13131A"/>
-                </a:solidFill>
-              </a:rPr>
-              <a:t>•  Who decides the threshold, and on what grounds?</a:t>
-            </a:r>
-            <a:endParaRPr lang="en-US" sz="1500"/>
+              <a:rPr lang="en-US" dirty="0">
+                <a:solidFill>
+                  <a:srgbClr val="13131A"/>
+                </a:solidFill>
+              </a:rPr>
+              <a:t>The standard choice is τ = 0.5, which is equivalent to classifying on the sign of the score z.</a:t>
+            </a:r>
+            <a:endParaRPr lang="en-US" dirty="0"/>
           </a:p>
           <a:p>
             <a:pPr>
@@ -6876,14 +6731,77 @@
               </a:spcAft>
             </a:pPr>
             <a:r>
-              <a:rPr lang="en-US" sz="1500">
-                <a:solidFill>
-                  <a:srgbClr val="13131A"/>
-                </a:solidFill>
-              </a:rPr>
-              <a:t>•  Can you run the whole pipeline yourself?</a:t>
-            </a:r>
-            <a:endParaRPr lang="en-US" sz="1500"/>
+              <a:rPr lang="en-US" sz="2000" b="1" dirty="0">
+                <a:solidFill>
+                  <a:srgbClr val="13131A"/>
+                </a:solidFill>
+              </a:rPr>
+              <a:t>Why τ = 0.5 is only a default</a:t>
+            </a:r>
+            <a:endParaRPr lang="en-US" sz="2000" dirty="0"/>
+          </a:p>
+          <a:p>
+            <a:pPr marL="285750" indent="-285750">
+              <a:spcBef>
+                <a:spcPts val="500"/>
+              </a:spcBef>
+              <a:spcAft>
+                <a:spcPts val="500"/>
+              </a:spcAft>
+              <a:buFont typeface="Arial" panose="020B0604020202020204" pitchFamily="34" charset="0"/>
+              <a:buChar char="•"/>
+            </a:pPr>
+            <a:r>
+              <a:rPr lang="en-US" dirty="0">
+                <a:solidFill>
+                  <a:srgbClr val="13131A"/>
+                </a:solidFill>
+              </a:rPr>
+              <a:t>It implicitly assumes a false positive and a false negative cost the same.</a:t>
+            </a:r>
+            <a:endParaRPr lang="en-US" dirty="0"/>
+          </a:p>
+          <a:p>
+            <a:pPr marL="285750" indent="-285750">
+              <a:spcBef>
+                <a:spcPts val="500"/>
+              </a:spcBef>
+              <a:spcAft>
+                <a:spcPts val="500"/>
+              </a:spcAft>
+              <a:buFont typeface="Arial" panose="020B0604020202020204" pitchFamily="34" charset="0"/>
+              <a:buChar char="•"/>
+            </a:pPr>
+            <a:r>
+              <a:rPr lang="en-US" dirty="0">
+                <a:solidFill>
+                  <a:srgbClr val="13131A"/>
+                </a:solidFill>
+              </a:rPr>
+              <a:t>Nothing in the fitting procedure chose it — the model never saw τ.</a:t>
+            </a:r>
+            <a:endParaRPr lang="en-US" dirty="0"/>
+          </a:p>
+          <a:p>
+            <a:pPr marL="285750" indent="-285750">
+              <a:spcBef>
+                <a:spcPts val="500"/>
+              </a:spcBef>
+              <a:spcAft>
+                <a:spcPts val="500"/>
+              </a:spcAft>
+              <a:buFont typeface="Arial" panose="020B0604020202020204" pitchFamily="34" charset="0"/>
+              <a:buChar char="•"/>
+            </a:pPr>
+            <a:r>
+              <a:rPr lang="en-US" dirty="0">
+                <a:solidFill>
+                  <a:srgbClr val="13131A"/>
+                </a:solidFill>
+              </a:rPr>
+              <a:t>Changing τ changes the predictions without refitting the model.</a:t>
+            </a:r>
+            <a:endParaRPr lang="en-US" dirty="0"/>
           </a:p>
         </p:txBody>
       </p:sp>
@@ -6921,7 +6839,7 @@
         <p:spPr>
           <a:xfrm>
             <a:off x="1981200" y="1029062"/>
-            <a:ext cx="7888378" cy="646331"/>
+            <a:ext cx="9500000" cy="646331"/>
           </a:xfrm>
           <a:prstGeom prst="rect">
             <a:avLst/>
@@ -6944,7 +6862,7 @@
                 </a:solidFill>
                 <a:latin typeface="+mj-lt"/>
               </a:rPr>
-              <a:t>Classification: The Decision Rule</a:t>
+              <a:t>Choosing the Threshold</a:t>
             </a:r>
           </a:p>
         </p:txBody>
@@ -6958,7 +6876,7 @@
         <p:spPr>
           <a:xfrm>
             <a:off x="1981200" y="1950000"/>
-            <a:ext cx="8229600" cy="3416320"/>
+            <a:ext cx="8229600" cy="3693319"/>
           </a:xfrm>
           <a:prstGeom prst="rect">
             <a:avLst/>
@@ -6980,70 +6898,12 @@
               </a:spcAft>
             </a:pPr>
             <a:r>
-              <a:rPr lang="en-US" dirty="0">
-                <a:solidFill>
-                  <a:srgbClr val="13131A"/>
-                </a:solidFill>
-              </a:rPr>
-              <a:t>Logistic regression outputs probabilities. Classification needs one more ingredient — a decision threshold τ:</a:t>
-            </a:r>
-            <a:endParaRPr lang="en-US" dirty="0"/>
-          </a:p>
-          <a:p>
-            <a:pPr>
-              <a:spcBef>
-                <a:spcPts val="500"/>
-              </a:spcBef>
-              <a:spcAft>
-                <a:spcPts val="500"/>
-              </a:spcAft>
-            </a:pPr>
-            <a:r>
-              <a:rPr lang="en-US" sz="2000" dirty="0">
-                <a:solidFill>
-                  <a:srgbClr val="13131A"/>
-                </a:solidFill>
-                <a:latin typeface="Cambria Math"/>
-              </a:rPr>
-              <a:t>ŷ = 1 if P(y = 1 | x) ≥ τ,   otherwise ŷ = 0</a:t>
-            </a:r>
-            <a:endParaRPr lang="en-US" sz="2000" dirty="0"/>
-          </a:p>
-          <a:p>
-            <a:pPr>
-              <a:spcBef>
-                <a:spcPts val="500"/>
-              </a:spcBef>
-              <a:spcAft>
-                <a:spcPts val="500"/>
-              </a:spcAft>
-            </a:pPr>
-            <a:r>
-              <a:rPr lang="en-US" dirty="0">
-                <a:solidFill>
-                  <a:srgbClr val="13131A"/>
-                </a:solidFill>
-              </a:rPr>
-              <a:t>The standard choice is τ = 0.5, which is equivalent to classifying on the sign of the score z.</a:t>
-            </a:r>
-            <a:endParaRPr lang="en-US" dirty="0"/>
-          </a:p>
-          <a:p>
-            <a:pPr>
-              <a:spcBef>
-                <a:spcPts val="500"/>
-              </a:spcBef>
-              <a:spcAft>
-                <a:spcPts val="500"/>
-              </a:spcAft>
-            </a:pPr>
-            <a:r>
               <a:rPr lang="en-US" sz="2000" b="1" dirty="0">
                 <a:solidFill>
                   <a:srgbClr val="13131A"/>
                 </a:solidFill>
               </a:rPr>
-              <a:t>Why τ = 0.5 is only a default</a:t>
+              <a:t>Set τ from the cost of each error type, not by habit.</a:t>
             </a:r>
             <a:endParaRPr lang="en-US" sz="2000" dirty="0"/>
           </a:p>
@@ -7064,7 +6924,7 @@
                   <a:srgbClr val="13131A"/>
                 </a:solidFill>
               </a:rPr>
-              <a:t>It implicitly assumes a false positive and a false negative cost the same.</a:t>
+              <a:t>Medical screening: a missed case (false negative) is far costlier than a false alarm, so lower τ — catch more positives and accept more false positives</a:t>
             </a:r>
             <a:endParaRPr lang="en-US" dirty="0"/>
           </a:p>
@@ -7085,7 +6945,7 @@
                   <a:srgbClr val="13131A"/>
                 </a:solidFill>
               </a:rPr>
-              <a:t>Nothing in the fitting procedure chose it — the model never saw τ.</a:t>
+              <a:t>Fraud review: each flag costs analyst time, so raise τ to protect precision</a:t>
             </a:r>
             <a:endParaRPr lang="en-US" dirty="0"/>
           </a:p>
@@ -7106,7 +6966,64 @@
                   <a:srgbClr val="13131A"/>
                 </a:solidFill>
               </a:rPr>
-              <a:t>Changing τ changes the predictions without refitting the model.</a:t>
+              <a:t>Credit default: a lender who loses more on a bad loan than on a declined application should lower τ</a:t>
+            </a:r>
+            <a:endParaRPr lang="en-US" dirty="0"/>
+          </a:p>
+          <a:p>
+            <a:pPr>
+              <a:spcBef>
+                <a:spcPts val="500"/>
+              </a:spcBef>
+              <a:spcAft>
+                <a:spcPts val="500"/>
+              </a:spcAft>
+            </a:pPr>
+            <a:r>
+              <a:rPr lang="en-US" sz="2000" b="1" dirty="0">
+                <a:solidFill>
+                  <a:srgbClr val="13131A"/>
+                </a:solidFill>
+              </a:rPr>
+              <a:t>Types of mistakes</a:t>
+            </a:r>
+            <a:endParaRPr lang="en-US" sz="2000" dirty="0"/>
+          </a:p>
+          <a:p>
+            <a:pPr>
+              <a:spcBef>
+                <a:spcPts val="500"/>
+              </a:spcBef>
+              <a:spcAft>
+                <a:spcPts val="500"/>
+              </a:spcAft>
+            </a:pPr>
+            <a:r>
+              <a:rPr lang="en-US" dirty="0">
+                <a:solidFill>
+                  <a:srgbClr val="13131A"/>
+                </a:solidFill>
+              </a:rPr>
+              <a:t>False positive: predicted 1, actually 0.   False negative: predicted 0, actually 1.</a:t>
+            </a:r>
+            <a:endParaRPr lang="en-US" dirty="0"/>
+          </a:p>
+          <a:p>
+            <a:pPr>
+              <a:spcBef>
+                <a:spcPts val="500"/>
+              </a:spcBef>
+              <a:spcAft>
+                <a:spcPts val="500"/>
+              </a:spcAft>
+            </a:pPr>
+            <a:r>
+              <a:rPr lang="en-US" dirty="0">
+                <a:solidFill>
+                  <a:srgbClr val="13131A"/>
+                </a:solidFill>
+              </a:rPr>
+              <a:t>Sweeping τ from 0 to 1 traces the ROC and precision–recall curves — the subject of the next lecture.</a:t>
             </a:r>
             <a:endParaRPr lang="en-US" dirty="0"/>
           </a:p>
@@ -7146,7 +7063,7 @@
         <p:spPr>
           <a:xfrm>
             <a:off x="1981200" y="1029062"/>
-            <a:ext cx="9500000" cy="646331"/>
+            <a:ext cx="6621941" cy="646331"/>
           </a:xfrm>
           <a:prstGeom prst="rect">
             <a:avLst/>
@@ -7163,13 +7080,13 @@
               <a:defRPr sz="3600" b="1"/>
             </a:pPr>
             <a:r>
-              <a:rPr lang="en-US" sz="3600" b="1" cap="all">
+              <a:rPr lang="en-US" sz="3600" b="1" cap="all" dirty="0">
                 <a:solidFill>
                   <a:srgbClr val="13131A"/>
                 </a:solidFill>
                 <a:latin typeface="+mj-lt"/>
               </a:rPr>
-              <a:t>Choosing the Threshold</a:t>
+              <a:t>Check Your Understanding</a:t>
             </a:r>
           </a:p>
         </p:txBody>
@@ -7183,7 +7100,7 @@
         <p:spPr>
           <a:xfrm>
             <a:off x="1981200" y="1950000"/>
-            <a:ext cx="8229600" cy="3693319"/>
+            <a:ext cx="8229600" cy="3544560"/>
           </a:xfrm>
           <a:prstGeom prst="rect">
             <a:avLst/>
@@ -7205,75 +7122,147 @@
               </a:spcAft>
             </a:pPr>
             <a:r>
-              <a:rPr lang="en-US" sz="2000" b="1" dirty="0">
-                <a:solidFill>
-                  <a:srgbClr val="13131A"/>
-                </a:solidFill>
-              </a:rPr>
-              <a:t>Set τ from the cost of each error type, not by habit.</a:t>
-            </a:r>
-            <a:endParaRPr lang="en-US" sz="2000" dirty="0"/>
-          </a:p>
-          <a:p>
-            <a:pPr marL="285750" indent="-285750">
-              <a:spcBef>
-                <a:spcPts val="500"/>
-              </a:spcBef>
-              <a:spcAft>
-                <a:spcPts val="500"/>
-              </a:spcAft>
-              <a:buFont typeface="Arial" panose="020B0604020202020204" pitchFamily="34" charset="0"/>
-              <a:buChar char="•"/>
+              <a:rPr lang="en-US" sz="1600" dirty="0">
+                <a:solidFill>
+                  <a:srgbClr val="13131A"/>
+                </a:solidFill>
+              </a:rPr>
+              <a:t>A model fit to the Default data (balance in $1,000s) gives w = 2.0, b = −7.0. For a customer with a $2,000 balance (x = 2.0), work out the predicted probability and the class label.</a:t>
+            </a:r>
+            <a:endParaRPr lang="en-US" sz="1600" dirty="0"/>
+          </a:p>
+          <a:p>
+            <a:pPr>
+              <a:spcBef>
+                <a:spcPts val="500"/>
+              </a:spcBef>
+              <a:spcAft>
+                <a:spcPts val="500"/>
+              </a:spcAft>
+            </a:pPr>
+            <a:r>
+              <a:rPr lang="en-US" sz="1600" b="1" dirty="0">
+                <a:solidFill>
+                  <a:srgbClr val="13131A"/>
+                </a:solidFill>
+              </a:rPr>
+              <a:t>Step 1 — compute the score</a:t>
+            </a:r>
+            <a:endParaRPr lang="en-US" sz="1600" dirty="0"/>
+          </a:p>
+          <a:p>
+            <a:pPr>
+              <a:spcBef>
+                <a:spcPts val="500"/>
+              </a:spcBef>
+              <a:spcAft>
+                <a:spcPts val="500"/>
+              </a:spcAft>
             </a:pPr>
             <a:r>
               <a:rPr lang="en-US" dirty="0">
                 <a:solidFill>
                   <a:srgbClr val="13131A"/>
                 </a:solidFill>
-              </a:rPr>
-              <a:t>Medical screening: a missed case (false negative) is far costlier than a false alarm, so lower τ — catch more positives and accept more false positives</a:t>
+                <a:latin typeface="Cambria Math"/>
+              </a:rPr>
+              <a:t>z = </a:t>
+            </a:r>
+            <a:r>
+              <a:rPr lang="en-US" dirty="0" err="1">
+                <a:solidFill>
+                  <a:srgbClr val="13131A"/>
+                </a:solidFill>
+                <a:latin typeface="Cambria Math"/>
+              </a:rPr>
+              <a:t>wᵀx</a:t>
+            </a:r>
+            <a:r>
+              <a:rPr lang="en-US" dirty="0">
+                <a:solidFill>
+                  <a:srgbClr val="13131A"/>
+                </a:solidFill>
+                <a:latin typeface="Cambria Math"/>
+              </a:rPr>
+              <a:t> + b = 2.0(2.0) − 7.0 = −3.0</a:t>
             </a:r>
             <a:endParaRPr lang="en-US" dirty="0"/>
           </a:p>
           <a:p>
-            <a:pPr marL="285750" indent="-285750">
-              <a:spcBef>
-                <a:spcPts val="500"/>
-              </a:spcBef>
-              <a:spcAft>
-                <a:spcPts val="500"/>
-              </a:spcAft>
-              <a:buFont typeface="Arial" panose="020B0604020202020204" pitchFamily="34" charset="0"/>
-              <a:buChar char="•"/>
+            <a:pPr>
+              <a:spcBef>
+                <a:spcPts val="500"/>
+              </a:spcBef>
+              <a:spcAft>
+                <a:spcPts val="500"/>
+              </a:spcAft>
+            </a:pPr>
+            <a:r>
+              <a:rPr lang="en-US" sz="1600" b="1" dirty="0">
+                <a:solidFill>
+                  <a:srgbClr val="13131A"/>
+                </a:solidFill>
+              </a:rPr>
+              <a:t>Step 2 — convert the score to a probability</a:t>
+            </a:r>
+            <a:endParaRPr lang="en-US" sz="1600" dirty="0"/>
+          </a:p>
+          <a:p>
+            <a:pPr>
+              <a:spcBef>
+                <a:spcPts val="500"/>
+              </a:spcBef>
+              <a:spcAft>
+                <a:spcPts val="500"/>
+              </a:spcAft>
             </a:pPr>
             <a:r>
               <a:rPr lang="en-US" dirty="0">
                 <a:solidFill>
                   <a:srgbClr val="13131A"/>
                 </a:solidFill>
-              </a:rPr>
-              <a:t>Fraud review: each flag costs analyst time, so raise τ to protect precision</a:t>
+                <a:latin typeface="Cambria Math"/>
+              </a:rPr>
+              <a:t>p = σ(−3.0) = 1 / (1 + exp(3.0)) ≈ 0.047</a:t>
             </a:r>
             <a:endParaRPr lang="en-US" dirty="0"/>
           </a:p>
           <a:p>
-            <a:pPr marL="285750" indent="-285750">
-              <a:spcBef>
-                <a:spcPts val="500"/>
-              </a:spcBef>
-              <a:spcAft>
-                <a:spcPts val="500"/>
-              </a:spcAft>
-              <a:buFont typeface="Arial" panose="020B0604020202020204" pitchFamily="34" charset="0"/>
-              <a:buChar char="•"/>
+            <a:pPr>
+              <a:spcBef>
+                <a:spcPts val="500"/>
+              </a:spcBef>
+              <a:spcAft>
+                <a:spcPts val="500"/>
+              </a:spcAft>
+            </a:pPr>
+            <a:r>
+              <a:rPr lang="en-US" sz="1600" b="1" dirty="0">
+                <a:solidFill>
+                  <a:srgbClr val="13131A"/>
+                </a:solidFill>
+              </a:rPr>
+              <a:t>Step 3 — apply the decision rule</a:t>
+            </a:r>
+            <a:endParaRPr lang="en-US" sz="1600" dirty="0"/>
+          </a:p>
+          <a:p>
+            <a:pPr>
+              <a:spcBef>
+                <a:spcPts val="500"/>
+              </a:spcBef>
+              <a:spcAft>
+                <a:spcPts val="500"/>
+              </a:spcAft>
             </a:pPr>
             <a:r>
               <a:rPr lang="en-US" dirty="0">
                 <a:solidFill>
                   <a:srgbClr val="13131A"/>
                 </a:solidFill>
-              </a:rPr>
-              <a:t>Credit default: a lender who loses more on a bad loan than on a declined application should lower τ</a:t>
+                <a:latin typeface="Cambria Math"/>
+              </a:rPr>
+              <a:t>p = 0.047 &lt; τ = 0.5  ⇒  predict ŷ = 0 (no default)</a:t>
             </a:r>
             <a:endParaRPr lang="en-US" dirty="0"/>
           </a:p>
@@ -7287,52 +7276,14 @@
               </a:spcAft>
             </a:pPr>
             <a:r>
-              <a:rPr lang="en-US" sz="2000" b="1" dirty="0">
-                <a:solidFill>
-                  <a:srgbClr val="13131A"/>
-                </a:solidFill>
-              </a:rPr>
-              <a:t>Types of mistakes</a:t>
-            </a:r>
-            <a:endParaRPr lang="en-US" sz="2000" dirty="0"/>
-          </a:p>
-          <a:p>
-            <a:pPr>
-              <a:spcBef>
-                <a:spcPts val="500"/>
-              </a:spcBef>
-              <a:spcAft>
-                <a:spcPts val="500"/>
-              </a:spcAft>
-            </a:pPr>
-            <a:r>
-              <a:rPr lang="en-US" dirty="0">
-                <a:solidFill>
-                  <a:srgbClr val="13131A"/>
-                </a:solidFill>
-              </a:rPr>
-              <a:t>False positive: predicted 1, actually 0.   False negative: predicted 0, actually 1.</a:t>
-            </a:r>
-            <a:endParaRPr lang="en-US" dirty="0"/>
-          </a:p>
-          <a:p>
-            <a:pPr>
-              <a:spcBef>
-                <a:spcPts val="500"/>
-              </a:spcBef>
-              <a:spcAft>
-                <a:spcPts val="500"/>
-              </a:spcAft>
-            </a:pPr>
-            <a:r>
-              <a:rPr lang="en-US" dirty="0">
-                <a:solidFill>
-                  <a:srgbClr val="13131A"/>
-                </a:solidFill>
-              </a:rPr>
-              <a:t>Sweeping τ from 0 to 1 traces the ROC and precision–recall curves — the subject of the next lecture.</a:t>
-            </a:r>
-            <a:endParaRPr lang="en-US" dirty="0"/>
+              <a:rPr lang="en-US" sz="1600" b="1" dirty="0">
+                <a:solidFill>
+                  <a:srgbClr val="13131A"/>
+                </a:solidFill>
+              </a:rPr>
+              <a:t>Now try it yourself: what is the predicted class at a $4,000 balance, and what threshold would flip the $2,000 answer?</a:t>
+            </a:r>
+            <a:endParaRPr lang="en-US" sz="1600" dirty="0"/>
           </a:p>
         </p:txBody>
       </p:sp>
@@ -7370,264 +7321,6 @@
         <p:spPr>
           <a:xfrm>
             <a:off x="1981200" y="1029062"/>
-            <a:ext cx="6621941" cy="646331"/>
-          </a:xfrm>
-          <a:prstGeom prst="rect">
-            <a:avLst/>
-          </a:prstGeom>
-          <a:noFill/>
-        </p:spPr>
-        <p:txBody>
-          <a:bodyPr wrap="none">
-            <a:spAutoFit/>
-          </a:bodyPr>
-          <a:lstStyle/>
-          <a:p>
-            <a:pPr>
-              <a:defRPr sz="3600" b="1"/>
-            </a:pPr>
-            <a:r>
-              <a:rPr lang="en-US" sz="3600" b="1" cap="all" dirty="0">
-                <a:solidFill>
-                  <a:srgbClr val="13131A"/>
-                </a:solidFill>
-                <a:latin typeface="+mj-lt"/>
-              </a:rPr>
-              <a:t>Check Your Understanding</a:t>
-            </a:r>
-          </a:p>
-        </p:txBody>
-      </p:sp>
-      <p:sp>
-        <p:nvSpPr>
-          <p:cNvPr id="4" name="TextBox 3"/>
-          <p:cNvSpPr txBox="1"/>
-          <p:nvPr/>
-        </p:nvSpPr>
-        <p:spPr>
-          <a:xfrm>
-            <a:off x="1981200" y="1950000"/>
-            <a:ext cx="8229600" cy="3544560"/>
-          </a:xfrm>
-          <a:prstGeom prst="rect">
-            <a:avLst/>
-          </a:prstGeom>
-          <a:noFill/>
-        </p:spPr>
-        <p:txBody>
-          <a:bodyPr wrap="square">
-            <a:spAutoFit/>
-          </a:bodyPr>
-          <a:lstStyle/>
-          <a:p>
-            <a:pPr>
-              <a:spcBef>
-                <a:spcPts val="500"/>
-              </a:spcBef>
-              <a:spcAft>
-                <a:spcPts val="500"/>
-              </a:spcAft>
-            </a:pPr>
-            <a:r>
-              <a:rPr lang="en-US" sz="1600" dirty="0">
-                <a:solidFill>
-                  <a:srgbClr val="13131A"/>
-                </a:solidFill>
-              </a:rPr>
-              <a:t>A model fit to the Default data (balance in $1,000s) gives w = 2.0, b = −7.0. For a customer with a $2,000 balance (x = 2.0), work out the predicted probability and the class label.</a:t>
-            </a:r>
-            <a:endParaRPr lang="en-US" sz="1600" dirty="0"/>
-          </a:p>
-          <a:p>
-            <a:pPr>
-              <a:spcBef>
-                <a:spcPts val="500"/>
-              </a:spcBef>
-              <a:spcAft>
-                <a:spcPts val="500"/>
-              </a:spcAft>
-            </a:pPr>
-            <a:r>
-              <a:rPr lang="en-US" sz="1600" b="1" dirty="0">
-                <a:solidFill>
-                  <a:srgbClr val="13131A"/>
-                </a:solidFill>
-              </a:rPr>
-              <a:t>Step 1 — compute the score</a:t>
-            </a:r>
-            <a:endParaRPr lang="en-US" sz="1600" dirty="0"/>
-          </a:p>
-          <a:p>
-            <a:pPr>
-              <a:spcBef>
-                <a:spcPts val="500"/>
-              </a:spcBef>
-              <a:spcAft>
-                <a:spcPts val="500"/>
-              </a:spcAft>
-            </a:pPr>
-            <a:r>
-              <a:rPr lang="en-US" dirty="0">
-                <a:solidFill>
-                  <a:srgbClr val="13131A"/>
-                </a:solidFill>
-                <a:latin typeface="Cambria Math"/>
-              </a:rPr>
-              <a:t>z = </a:t>
-            </a:r>
-            <a:r>
-              <a:rPr lang="en-US" dirty="0" err="1">
-                <a:solidFill>
-                  <a:srgbClr val="13131A"/>
-                </a:solidFill>
-                <a:latin typeface="Cambria Math"/>
-              </a:rPr>
-              <a:t>wᵀx</a:t>
-            </a:r>
-            <a:r>
-              <a:rPr lang="en-US" dirty="0">
-                <a:solidFill>
-                  <a:srgbClr val="13131A"/>
-                </a:solidFill>
-                <a:latin typeface="Cambria Math"/>
-              </a:rPr>
-              <a:t> + b = 2.0(2.0) − 7.0 = −3.0</a:t>
-            </a:r>
-            <a:endParaRPr lang="en-US" dirty="0"/>
-          </a:p>
-          <a:p>
-            <a:pPr>
-              <a:spcBef>
-                <a:spcPts val="500"/>
-              </a:spcBef>
-              <a:spcAft>
-                <a:spcPts val="500"/>
-              </a:spcAft>
-            </a:pPr>
-            <a:r>
-              <a:rPr lang="en-US" sz="1600" b="1" dirty="0">
-                <a:solidFill>
-                  <a:srgbClr val="13131A"/>
-                </a:solidFill>
-              </a:rPr>
-              <a:t>Step 2 — convert the score to a probability</a:t>
-            </a:r>
-            <a:endParaRPr lang="en-US" sz="1600" dirty="0"/>
-          </a:p>
-          <a:p>
-            <a:pPr>
-              <a:spcBef>
-                <a:spcPts val="500"/>
-              </a:spcBef>
-              <a:spcAft>
-                <a:spcPts val="500"/>
-              </a:spcAft>
-            </a:pPr>
-            <a:r>
-              <a:rPr lang="en-US" dirty="0">
-                <a:solidFill>
-                  <a:srgbClr val="13131A"/>
-                </a:solidFill>
-                <a:latin typeface="Cambria Math"/>
-              </a:rPr>
-              <a:t>p = σ(−3.0) = 1 / (1 + exp(3.0)) ≈ 0.047</a:t>
-            </a:r>
-            <a:endParaRPr lang="en-US" dirty="0"/>
-          </a:p>
-          <a:p>
-            <a:pPr>
-              <a:spcBef>
-                <a:spcPts val="500"/>
-              </a:spcBef>
-              <a:spcAft>
-                <a:spcPts val="500"/>
-              </a:spcAft>
-            </a:pPr>
-            <a:r>
-              <a:rPr lang="en-US" sz="1600" b="1" dirty="0">
-                <a:solidFill>
-                  <a:srgbClr val="13131A"/>
-                </a:solidFill>
-              </a:rPr>
-              <a:t>Step 3 — apply the decision rule</a:t>
-            </a:r>
-            <a:endParaRPr lang="en-US" sz="1600" dirty="0"/>
-          </a:p>
-          <a:p>
-            <a:pPr>
-              <a:spcBef>
-                <a:spcPts val="500"/>
-              </a:spcBef>
-              <a:spcAft>
-                <a:spcPts val="500"/>
-              </a:spcAft>
-            </a:pPr>
-            <a:r>
-              <a:rPr lang="en-US" dirty="0">
-                <a:solidFill>
-                  <a:srgbClr val="13131A"/>
-                </a:solidFill>
-                <a:latin typeface="Cambria Math"/>
-              </a:rPr>
-              <a:t>p = 0.047 &lt; τ = 0.5  ⇒  predict ŷ = 0 (no default)</a:t>
-            </a:r>
-            <a:endParaRPr lang="en-US" dirty="0"/>
-          </a:p>
-          <a:p>
-            <a:pPr>
-              <a:spcBef>
-                <a:spcPts val="500"/>
-              </a:spcBef>
-              <a:spcAft>
-                <a:spcPts val="500"/>
-              </a:spcAft>
-            </a:pPr>
-            <a:r>
-              <a:rPr lang="en-US" sz="1600" b="1" dirty="0">
-                <a:solidFill>
-                  <a:srgbClr val="13131A"/>
-                </a:solidFill>
-              </a:rPr>
-              <a:t>Now try it yourself: what is the predicted class at a $4,000 balance, and what threshold would flip the $2,000 answer?</a:t>
-            </a:r>
-            <a:endParaRPr lang="en-US" sz="1600" dirty="0"/>
-          </a:p>
-        </p:txBody>
-      </p:sp>
-    </p:spTree>
-  </p:cSld>
-  <p:clrMapOvr>
-    <a:masterClrMapping/>
-  </p:clrMapOvr>
-</p:sld>
-</file>
-
-<file path=ppt/slides/slide19.xml><?xml version="1.0" encoding="utf-8"?>
-<p:sld xmlns:a="http://schemas.openxmlformats.org/drawingml/2006/main" xmlns:r="http://schemas.openxmlformats.org/officeDocument/2006/relationships" xmlns:p="http://schemas.openxmlformats.org/presentationml/2006/main">
-  <p:cSld>
-    <p:spTree>
-      <p:nvGrpSpPr>
-        <p:cNvPr id="1" name=""/>
-        <p:cNvGrpSpPr/>
-        <p:nvPr/>
-      </p:nvGrpSpPr>
-      <p:grpSpPr>
-        <a:xfrm>
-          <a:off x="0" y="0"/>
-          <a:ext cx="0" cy="0"/>
-          <a:chOff x="0" y="0"/>
-          <a:chExt cx="0" cy="0"/>
-        </a:xfrm>
-      </p:grpSpPr>
-      <p:sp>
-        <p:nvSpPr>
-          <p:cNvPr id="2" name="TextBox 1"/>
-          <p:cNvSpPr txBox="1"/>
-          <p:nvPr/>
-        </p:nvSpPr>
-        <p:spPr>
-          <a:xfrm>
-            <a:off x="1981200" y="1029062"/>
             <a:ext cx="9500000" cy="646331"/>
           </a:xfrm>
           <a:prstGeom prst="rect">
@@ -7919,251 +7612,6 @@
 </file>
 
 <file path=ppt/slides/slide2.xml><?xml version="1.0" encoding="utf-8"?>
-<p:sld xmlns:a="http://schemas.openxmlformats.org/drawingml/2006/main" xmlns:r="http://schemas.openxmlformats.org/officeDocument/2006/relationships" xmlns:p="http://schemas.openxmlformats.org/presentationml/2006/main">
-  <p:cSld>
-    <p:spTree>
-      <p:nvGrpSpPr>
-        <p:cNvPr id="1" name=""/>
-        <p:cNvGrpSpPr/>
-        <p:nvPr/>
-      </p:nvGrpSpPr>
-      <p:grpSpPr>
-        <a:xfrm>
-          <a:off x="0" y="0"/>
-          <a:ext cx="0" cy="0"/>
-          <a:chOff x="0" y="0"/>
-          <a:chExt cx="0" cy="0"/>
-        </a:xfrm>
-      </p:grpSpPr>
-      <p:sp>
-        <p:nvSpPr>
-          <p:cNvPr id="2" name="TextBox 1"/>
-          <p:cNvSpPr txBox="1"/>
-          <p:nvPr/>
-        </p:nvSpPr>
-        <p:spPr>
-          <a:xfrm>
-            <a:off x="1981200" y="1029062"/>
-            <a:ext cx="1976823" cy="646331"/>
-          </a:xfrm>
-          <a:prstGeom prst="rect">
-            <a:avLst/>
-          </a:prstGeom>
-          <a:noFill/>
-        </p:spPr>
-        <p:txBody>
-          <a:bodyPr wrap="none">
-            <a:spAutoFit/>
-          </a:bodyPr>
-          <a:lstStyle/>
-          <a:p>
-            <a:pPr>
-              <a:defRPr sz="3600" b="1"/>
-            </a:pPr>
-            <a:r>
-              <a:rPr lang="en-US" sz="3600" b="1" cap="all" dirty="0">
-                <a:solidFill>
-                  <a:srgbClr val="13131A"/>
-                </a:solidFill>
-                <a:latin typeface="+mj-lt"/>
-              </a:rPr>
-              <a:t>Outline</a:t>
-            </a:r>
-          </a:p>
-        </p:txBody>
-      </p:sp>
-      <p:sp>
-        <p:nvSpPr>
-          <p:cNvPr id="4" name="TextBox 3"/>
-          <p:cNvSpPr txBox="1"/>
-          <p:nvPr/>
-        </p:nvSpPr>
-        <p:spPr>
-          <a:xfrm>
-            <a:off x="1981200" y="1950000"/>
-            <a:ext cx="8229600" cy="3098284"/>
-          </a:xfrm>
-          <a:prstGeom prst="rect">
-            <a:avLst/>
-          </a:prstGeom>
-          <a:noFill/>
-        </p:spPr>
-        <p:txBody>
-          <a:bodyPr wrap="square">
-            <a:spAutoFit/>
-          </a:bodyPr>
-          <a:lstStyle/>
-          <a:p>
-            <a:pPr>
-              <a:spcBef>
-                <a:spcPts val="500"/>
-              </a:spcBef>
-              <a:spcAft>
-                <a:spcPts val="500"/>
-              </a:spcAft>
-            </a:pPr>
-            <a:r>
-              <a:rPr lang="en-US" sz="1600" dirty="0">
-                <a:solidFill>
-                  <a:srgbClr val="13131A"/>
-                </a:solidFill>
-              </a:rPr>
-              <a:t>One idea runs through the whole lecture: keep the linear score z = </a:t>
-            </a:r>
-            <a:r>
-              <a:rPr lang="en-US" sz="1600" dirty="0" err="1">
-                <a:solidFill>
-                  <a:srgbClr val="13131A"/>
-                </a:solidFill>
-              </a:rPr>
-              <a:t>wᵀx</a:t>
-            </a:r>
-            <a:r>
-              <a:rPr lang="en-US" sz="1600" dirty="0">
-                <a:solidFill>
-                  <a:srgbClr val="13131A"/>
-                </a:solidFill>
-              </a:rPr>
-              <a:t> + b, and change what we do with it.</a:t>
-            </a:r>
-            <a:endParaRPr lang="en-US" sz="1600" dirty="0"/>
-          </a:p>
-          <a:p>
-            <a:pPr>
-              <a:spcBef>
-                <a:spcPts val="500"/>
-              </a:spcBef>
-              <a:spcAft>
-                <a:spcPts val="500"/>
-              </a:spcAft>
-            </a:pPr>
-            <a:endParaRPr lang="en-US" sz="1200" dirty="0"/>
-          </a:p>
-          <a:p>
-            <a:pPr>
-              <a:spcBef>
-                <a:spcPts val="500"/>
-              </a:spcBef>
-              <a:spcAft>
-                <a:spcPts val="500"/>
-              </a:spcAft>
-            </a:pPr>
-            <a:r>
-              <a:rPr lang="en-US" sz="1600" b="1" dirty="0">
-                <a:solidFill>
-                  <a:srgbClr val="13131A"/>
-                </a:solidFill>
-              </a:rPr>
-              <a:t>Part 1 — Setting Up the Model</a:t>
-            </a:r>
-            <a:endParaRPr lang="en-US" sz="1600" dirty="0"/>
-          </a:p>
-          <a:p>
-            <a:pPr>
-              <a:spcBef>
-                <a:spcPts val="500"/>
-              </a:spcBef>
-              <a:spcAft>
-                <a:spcPts val="500"/>
-              </a:spcAft>
-            </a:pPr>
-            <a:r>
-              <a:rPr lang="en-US" sz="1500" dirty="0">
-                <a:solidFill>
-                  <a:srgbClr val="13131A"/>
-                </a:solidFill>
-              </a:rPr>
-              <a:t>How do we adapt linear regression for a (probabilistic) classifier?</a:t>
-            </a:r>
-            <a:endParaRPr lang="en-US" sz="1500" dirty="0"/>
-          </a:p>
-          <a:p>
-            <a:pPr>
-              <a:spcBef>
-                <a:spcPts val="500"/>
-              </a:spcBef>
-              <a:spcAft>
-                <a:spcPts val="500"/>
-              </a:spcAft>
-            </a:pPr>
-            <a:r>
-              <a:rPr lang="en-US" sz="1600" b="1" dirty="0">
-                <a:solidFill>
-                  <a:srgbClr val="13131A"/>
-                </a:solidFill>
-              </a:rPr>
-              <a:t>Part 2 — Fitting the Model</a:t>
-            </a:r>
-            <a:endParaRPr lang="en-US" sz="1600" dirty="0"/>
-          </a:p>
-          <a:p>
-            <a:pPr>
-              <a:spcBef>
-                <a:spcPts val="500"/>
-              </a:spcBef>
-              <a:spcAft>
-                <a:spcPts val="500"/>
-              </a:spcAft>
-            </a:pPr>
-            <a:r>
-              <a:rPr lang="en-US" sz="1500" dirty="0">
-                <a:solidFill>
-                  <a:srgbClr val="13131A"/>
-                </a:solidFill>
-              </a:rPr>
-              <a:t>How do we learn the parameters of this model? (w and b)</a:t>
-            </a:r>
-            <a:endParaRPr lang="en-US" sz="1500" dirty="0"/>
-          </a:p>
-          <a:p>
-            <a:pPr>
-              <a:spcBef>
-                <a:spcPts val="500"/>
-              </a:spcBef>
-              <a:spcAft>
-                <a:spcPts val="500"/>
-              </a:spcAft>
-            </a:pPr>
-            <a:r>
-              <a:rPr lang="en-US" sz="1600" b="1" dirty="0">
-                <a:solidFill>
-                  <a:srgbClr val="13131A"/>
-                </a:solidFill>
-              </a:rPr>
-              <a:t>Part 3 — Using the Model</a:t>
-            </a:r>
-            <a:endParaRPr lang="en-US" sz="1600" dirty="0"/>
-          </a:p>
-          <a:p>
-            <a:pPr>
-              <a:spcBef>
-                <a:spcPts val="500"/>
-              </a:spcBef>
-              <a:spcAft>
-                <a:spcPts val="500"/>
-              </a:spcAft>
-            </a:pPr>
-            <a:r>
-              <a:rPr lang="en-US" sz="1500" dirty="0">
-                <a:solidFill>
-                  <a:srgbClr val="13131A"/>
-                </a:solidFill>
-              </a:rPr>
-              <a:t>How do we turn a probability into a decision, and how do we check our work?</a:t>
-            </a:r>
-            <a:endParaRPr lang="en-US" sz="1500" dirty="0"/>
-          </a:p>
-        </p:txBody>
-      </p:sp>
-    </p:spTree>
-  </p:cSld>
-  <p:clrMapOvr>
-    <a:masterClrMapping/>
-  </p:clrMapOvr>
-</p:sld>
-</file>
-
-<file path=ppt/slides/slide3.xml><?xml version="1.0" encoding="utf-8"?>
 <p:sld xmlns:a="http://schemas.openxmlformats.org/drawingml/2006/main" xmlns:r="http://schemas.openxmlformats.org/officeDocument/2006/relationships" xmlns:p="http://schemas.openxmlformats.org/presentationml/2006/main">
   <p:cSld>
     <p:spTree>
@@ -8519,7 +7967,7 @@
 </p:sld>
 </file>
 
-<file path=ppt/slides/slide4.xml><?xml version="1.0" encoding="utf-8"?>
+<file path=ppt/slides/slide3.xml><?xml version="1.0" encoding="utf-8"?>
 <p:sld xmlns:a="http://schemas.openxmlformats.org/drawingml/2006/main" xmlns:r="http://schemas.openxmlformats.org/officeDocument/2006/relationships" xmlns:p="http://schemas.openxmlformats.org/presentationml/2006/main">
   <p:cSld>
     <p:spTree>
@@ -8745,194 +8193,7 @@
 </p:sld>
 </file>
 
-<file path=ppt/slides/slide5.xml><?xml version="1.0" encoding="utf-8"?>
-<p:sld xmlns:a="http://schemas.openxmlformats.org/drawingml/2006/main" xmlns:r="http://schemas.openxmlformats.org/officeDocument/2006/relationships" xmlns:p="http://schemas.openxmlformats.org/presentationml/2006/main">
-  <p:cSld>
-    <p:spTree>
-      <p:nvGrpSpPr>
-        <p:cNvPr id="1" name=""/>
-        <p:cNvGrpSpPr/>
-        <p:nvPr/>
-      </p:nvGrpSpPr>
-      <p:grpSpPr>
-        <a:xfrm>
-          <a:off x="0" y="0"/>
-          <a:ext cx="0" cy="0"/>
-          <a:chOff x="0" y="0"/>
-          <a:chExt cx="0" cy="0"/>
-        </a:xfrm>
-      </p:grpSpPr>
-      <p:sp>
-        <p:nvSpPr>
-          <p:cNvPr id="2" name="TextBox 1"/>
-          <p:cNvSpPr txBox="1"/>
-          <p:nvPr/>
-        </p:nvSpPr>
-        <p:spPr>
-          <a:xfrm>
-            <a:off x="1981200" y="1029062"/>
-            <a:ext cx="9500000" cy="646331"/>
-          </a:xfrm>
-          <a:prstGeom prst="rect">
-            <a:avLst/>
-          </a:prstGeom>
-          <a:noFill/>
-        </p:spPr>
-        <p:txBody>
-          <a:bodyPr wrap="none">
-            <a:spAutoFit/>
-          </a:bodyPr>
-          <a:lstStyle/>
-          <a:p>
-            <a:pPr>
-              <a:defRPr sz="3600" b="1"/>
-            </a:pPr>
-            <a:r>
-              <a:rPr lang="en-US" sz="3600" b="1" cap="all">
-                <a:solidFill>
-                  <a:srgbClr val="13131A"/>
-                </a:solidFill>
-                <a:latin typeface="+mj-lt"/>
-              </a:rPr>
-              <a:t>Linear vs. Logistic, Side by Side</a:t>
-            </a:r>
-          </a:p>
-        </p:txBody>
-      </p:sp>
-      <p:sp>
-        <p:nvSpPr>
-          <p:cNvPr id="4" name="TextBox 3"/>
-          <p:cNvSpPr txBox="1"/>
-          <p:nvPr/>
-        </p:nvSpPr>
-        <p:spPr>
-          <a:xfrm>
-            <a:off x="1981200" y="1790000"/>
-            <a:ext cx="8229600" cy="862568"/>
-          </a:xfrm>
-          <a:prstGeom prst="rect">
-            <a:avLst/>
-          </a:prstGeom>
-          <a:noFill/>
-        </p:spPr>
-        <p:txBody>
-          <a:bodyPr wrap="square">
-            <a:normAutofit lnSpcReduction="10000"/>
-          </a:bodyPr>
-          <a:lstStyle/>
-          <a:p>
-            <a:pPr>
-              <a:spcBef>
-                <a:spcPts val="500"/>
-              </a:spcBef>
-              <a:spcAft>
-                <a:spcPts val="500"/>
-              </a:spcAft>
-            </a:pPr>
-            <a:r>
-              <a:rPr lang="en-US" sz="1500" dirty="0">
-                <a:solidFill>
-                  <a:srgbClr val="13131A"/>
-                </a:solidFill>
-              </a:rPr>
-              <a:t>Both panels fit default probability against account balance.</a:t>
-            </a:r>
-            <a:endParaRPr lang="en-US" sz="1500" dirty="0"/>
-          </a:p>
-          <a:p>
-            <a:pPr>
-              <a:spcBef>
-                <a:spcPts val="500"/>
-              </a:spcBef>
-              <a:spcAft>
-                <a:spcPts val="500"/>
-              </a:spcAft>
-            </a:pPr>
-            <a:r>
-              <a:rPr lang="en-US" sz="1500" dirty="0">
-                <a:solidFill>
-                  <a:srgbClr val="13131A"/>
-                </a:solidFill>
-              </a:rPr>
-              <a:t>Left: the linear fit leaves the [0,1] range, predicting negative probabilities at low balances.  Right: the sigmoid fit stays in (0,1) and bends where default risk actually changes.</a:t>
-            </a:r>
-            <a:endParaRPr lang="en-US" sz="1500" dirty="0"/>
-          </a:p>
-        </p:txBody>
-      </p:sp>
-      <p:pic>
-        <p:nvPicPr>
-          <p:cNvPr id="7" name="Linear versus logistic fit to the Default data"/>
-          <p:cNvPicPr/>
-          <p:nvPr/>
-        </p:nvPicPr>
-        <p:blipFill>
-          <a:blip r:embed="rId3"/>
-          <a:stretch>
-            <a:fillRect/>
-          </a:stretch>
-        </p:blipFill>
-        <p:spPr>
-          <a:xfrm>
-            <a:off x="2300000" y="2680000"/>
-            <a:ext cx="7600000" cy="2954000"/>
-          </a:xfrm>
-          <a:prstGeom prst="rect">
-            <a:avLst/>
-          </a:prstGeom>
-        </p:spPr>
-      </p:pic>
-      <p:sp>
-        <p:nvSpPr>
-          <p:cNvPr id="9" name="TextBox 9"/>
-          <p:cNvSpPr txBox="1"/>
-          <p:nvPr/>
-        </p:nvSpPr>
-        <p:spPr>
-          <a:xfrm>
-            <a:off x="1981200" y="5770000"/>
-            <a:ext cx="8229600" cy="230000"/>
-          </a:xfrm>
-          <a:prstGeom prst="rect">
-            <a:avLst/>
-          </a:prstGeom>
-          <a:noFill/>
-        </p:spPr>
-        <p:txBody>
-          <a:bodyPr wrap="square">
-            <a:spAutoFit/>
-          </a:bodyPr>
-          <a:lstStyle/>
-          <a:p>
-            <a:pPr>
-              <a:spcBef>
-                <a:spcPts val="500"/>
-              </a:spcBef>
-              <a:spcAft>
-                <a:spcPts val="500"/>
-              </a:spcAft>
-            </a:pPr>
-            <a:r>
-              <a:rPr lang="en-US" sz="1100">
-                <a:solidFill>
-                  <a:srgbClr val="13131A"/>
-                </a:solidFill>
-              </a:rPr>
-              <a:t>Figure from Introduction to Statistical Learning by James et al.</a:t>
-            </a:r>
-            <a:endParaRPr lang="en-US" sz="1100"/>
-          </a:p>
-        </p:txBody>
-      </p:sp>
-    </p:spTree>
-  </p:cSld>
-  <p:clrMapOvr>
-    <a:masterClrMapping/>
-  </p:clrMapOvr>
-</p:sld>
-</file>
-
-<file path=ppt/slides/slide6.xml><?xml version="1.0" encoding="utf-8"?>
+<file path=ppt/slides/slide4.xml><?xml version="1.0" encoding="utf-8"?>
 <p:sld xmlns:a="http://schemas.openxmlformats.org/drawingml/2006/main" xmlns:r="http://schemas.openxmlformats.org/officeDocument/2006/relationships" xmlns:p="http://schemas.openxmlformats.org/presentationml/2006/main">
   <p:cSld>
     <p:spTree>
@@ -9691,6 +8952,576 @@
 </p:sld>
 </file>
 
+<file path=ppt/slides/slide5.xml><?xml version="1.0" encoding="utf-8"?>
+<p:sld xmlns:a="http://schemas.openxmlformats.org/drawingml/2006/main" xmlns:r="http://schemas.openxmlformats.org/officeDocument/2006/relationships" xmlns:p="http://schemas.openxmlformats.org/presentationml/2006/main">
+  <p:cSld>
+    <p:spTree>
+      <p:nvGrpSpPr>
+        <p:cNvPr id="1" name=""/>
+        <p:cNvGrpSpPr/>
+        <p:nvPr/>
+      </p:nvGrpSpPr>
+      <p:grpSpPr>
+        <a:xfrm>
+          <a:off x="0" y="0"/>
+          <a:ext cx="0" cy="0"/>
+          <a:chOff x="0" y="0"/>
+          <a:chExt cx="0" cy="0"/>
+        </a:xfrm>
+      </p:grpSpPr>
+      <p:sp>
+        <p:nvSpPr>
+          <p:cNvPr id="2" name="TextBox 1"/>
+          <p:cNvSpPr txBox="1"/>
+          <p:nvPr/>
+        </p:nvSpPr>
+        <p:spPr>
+          <a:xfrm>
+            <a:off x="1981200" y="1029062"/>
+            <a:ext cx="9500000" cy="646331"/>
+          </a:xfrm>
+          <a:prstGeom prst="rect">
+            <a:avLst/>
+          </a:prstGeom>
+          <a:noFill/>
+        </p:spPr>
+        <p:txBody>
+          <a:bodyPr wrap="none">
+            <a:spAutoFit/>
+          </a:bodyPr>
+          <a:lstStyle/>
+          <a:p>
+            <a:pPr>
+              <a:defRPr sz="3600" b="1"/>
+            </a:pPr>
+            <a:r>
+              <a:rPr lang="en-US" sz="3600" b="1" cap="all">
+                <a:solidFill>
+                  <a:srgbClr val="13131A"/>
+                </a:solidFill>
+                <a:latin typeface="+mj-lt"/>
+              </a:rPr>
+              <a:t>Linear vs. Logistic, Side by Side</a:t>
+            </a:r>
+          </a:p>
+        </p:txBody>
+      </p:sp>
+      <p:sp>
+        <p:nvSpPr>
+          <p:cNvPr id="4" name="TextBox 3"/>
+          <p:cNvSpPr txBox="1"/>
+          <p:nvPr/>
+        </p:nvSpPr>
+        <p:spPr>
+          <a:xfrm>
+            <a:off x="1981200" y="1790000"/>
+            <a:ext cx="8229600" cy="862568"/>
+          </a:xfrm>
+          <a:prstGeom prst="rect">
+            <a:avLst/>
+          </a:prstGeom>
+          <a:noFill/>
+        </p:spPr>
+        <p:txBody>
+          <a:bodyPr wrap="square">
+            <a:normAutofit lnSpcReduction="10000"/>
+          </a:bodyPr>
+          <a:lstStyle/>
+          <a:p>
+            <a:pPr>
+              <a:spcBef>
+                <a:spcPts val="500"/>
+              </a:spcBef>
+              <a:spcAft>
+                <a:spcPts val="500"/>
+              </a:spcAft>
+            </a:pPr>
+            <a:r>
+              <a:rPr lang="en-US" sz="1500" dirty="0">
+                <a:solidFill>
+                  <a:srgbClr val="13131A"/>
+                </a:solidFill>
+              </a:rPr>
+              <a:t>Both panels fit default probability against account balance.</a:t>
+            </a:r>
+            <a:endParaRPr lang="en-US" sz="1500" dirty="0"/>
+          </a:p>
+          <a:p>
+            <a:pPr>
+              <a:spcBef>
+                <a:spcPts val="500"/>
+              </a:spcBef>
+              <a:spcAft>
+                <a:spcPts val="500"/>
+              </a:spcAft>
+            </a:pPr>
+            <a:r>
+              <a:rPr lang="en-US" sz="1500" dirty="0">
+                <a:solidFill>
+                  <a:srgbClr val="13131A"/>
+                </a:solidFill>
+              </a:rPr>
+              <a:t>Left: the linear fit leaves the [0,1] range, predicting negative probabilities at low balances.  Right: the sigmoid fit stays in (0,1) and bends where default risk actually changes.</a:t>
+            </a:r>
+            <a:endParaRPr lang="en-US" sz="1500" dirty="0"/>
+          </a:p>
+        </p:txBody>
+      </p:sp>
+      <p:pic>
+        <p:nvPicPr>
+          <p:cNvPr id="7" name="Linear versus logistic fit to the Default data"/>
+          <p:cNvPicPr/>
+          <p:nvPr/>
+        </p:nvPicPr>
+        <p:blipFill>
+          <a:blip r:embed="rId3"/>
+          <a:stretch>
+            <a:fillRect/>
+          </a:stretch>
+        </p:blipFill>
+        <p:spPr>
+          <a:xfrm>
+            <a:off x="2300000" y="2680000"/>
+            <a:ext cx="7600000" cy="2954000"/>
+          </a:xfrm>
+          <a:prstGeom prst="rect">
+            <a:avLst/>
+          </a:prstGeom>
+        </p:spPr>
+      </p:pic>
+      <p:sp>
+        <p:nvSpPr>
+          <p:cNvPr id="9" name="TextBox 9"/>
+          <p:cNvSpPr txBox="1"/>
+          <p:nvPr/>
+        </p:nvSpPr>
+        <p:spPr>
+          <a:xfrm>
+            <a:off x="1981200" y="5770000"/>
+            <a:ext cx="8229600" cy="230000"/>
+          </a:xfrm>
+          <a:prstGeom prst="rect">
+            <a:avLst/>
+          </a:prstGeom>
+          <a:noFill/>
+        </p:spPr>
+        <p:txBody>
+          <a:bodyPr wrap="square">
+            <a:spAutoFit/>
+          </a:bodyPr>
+          <a:lstStyle/>
+          <a:p>
+            <a:pPr>
+              <a:spcBef>
+                <a:spcPts val="500"/>
+              </a:spcBef>
+              <a:spcAft>
+                <a:spcPts val="500"/>
+              </a:spcAft>
+            </a:pPr>
+            <a:r>
+              <a:rPr lang="en-US" sz="1100">
+                <a:solidFill>
+                  <a:srgbClr val="13131A"/>
+                </a:solidFill>
+              </a:rPr>
+              <a:t>Figure from Introduction to Statistical Learning by James et al.</a:t>
+            </a:r>
+            <a:endParaRPr lang="en-US" sz="1100"/>
+          </a:p>
+        </p:txBody>
+      </p:sp>
+    </p:spTree>
+  </p:cSld>
+  <p:clrMapOvr>
+    <a:masterClrMapping/>
+  </p:clrMapOvr>
+</p:sld>
+</file>
+
+<file path=ppt/slides/slide6.xml><?xml version="1.0" encoding="utf-8"?>
+<p:sld xmlns:a="http://schemas.openxmlformats.org/drawingml/2006/main" xmlns:r="http://schemas.openxmlformats.org/officeDocument/2006/relationships" xmlns:p="http://schemas.openxmlformats.org/presentationml/2006/main">
+  <p:cSld>
+    <p:spTree>
+      <p:nvGrpSpPr>
+        <p:cNvPr id="1" name=""/>
+        <p:cNvGrpSpPr/>
+        <p:nvPr/>
+      </p:nvGrpSpPr>
+      <p:grpSpPr>
+        <a:xfrm>
+          <a:off x="0" y="0"/>
+          <a:ext cx="0" cy="0"/>
+          <a:chOff x="0" y="0"/>
+          <a:chExt cx="0" cy="0"/>
+        </a:xfrm>
+      </p:grpSpPr>
+      <p:sp>
+        <p:nvSpPr>
+          <p:cNvPr id="2" name="TextBox 1"/>
+          <p:cNvSpPr txBox="1"/>
+          <p:nvPr/>
+        </p:nvSpPr>
+        <p:spPr>
+          <a:xfrm>
+            <a:off x="1981200" y="1029062"/>
+            <a:ext cx="9500000" cy="646331"/>
+          </a:xfrm>
+          <a:prstGeom prst="rect">
+            <a:avLst/>
+          </a:prstGeom>
+          <a:noFill/>
+        </p:spPr>
+        <p:txBody>
+          <a:bodyPr wrap="none">
+            <a:spAutoFit/>
+          </a:bodyPr>
+          <a:lstStyle/>
+          <a:p>
+            <a:pPr>
+              <a:defRPr sz="3600" b="1"/>
+            </a:pPr>
+            <a:r>
+              <a:rPr lang="en-US" sz="3600" b="1" cap="all">
+                <a:solidFill>
+                  <a:srgbClr val="13131A"/>
+                </a:solidFill>
+                <a:latin typeface="+mj-lt"/>
+              </a:rPr>
+              <a:t>Odds and the Logit</a:t>
+            </a:r>
+          </a:p>
+        </p:txBody>
+      </p:sp>
+      <p:sp>
+        <p:nvSpPr>
+          <p:cNvPr id="4" name="TextBox 3"/>
+          <p:cNvSpPr txBox="1"/>
+          <p:nvPr/>
+        </p:nvSpPr>
+        <p:spPr>
+          <a:xfrm>
+            <a:off x="1981200" y="1900000"/>
+            <a:ext cx="3900000" cy="2518638"/>
+          </a:xfrm>
+          <a:prstGeom prst="rect">
+            <a:avLst/>
+          </a:prstGeom>
+          <a:noFill/>
+        </p:spPr>
+        <p:txBody>
+          <a:bodyPr wrap="square">
+            <a:spAutoFit/>
+          </a:bodyPr>
+          <a:lstStyle/>
+          <a:p>
+            <a:pPr>
+              <a:spcBef>
+                <a:spcPts val="500"/>
+              </a:spcBef>
+              <a:spcAft>
+                <a:spcPts val="500"/>
+              </a:spcAft>
+            </a:pPr>
+            <a:r>
+              <a:rPr lang="en-US" sz="1600" b="1" dirty="0">
+                <a:solidFill>
+                  <a:srgbClr val="13131A"/>
+                </a:solidFill>
+              </a:rPr>
+              <a:t>Odds</a:t>
+            </a:r>
+            <a:endParaRPr lang="en-US" sz="1600" dirty="0"/>
+          </a:p>
+          <a:p>
+            <a:pPr>
+              <a:spcBef>
+                <a:spcPts val="500"/>
+              </a:spcBef>
+              <a:spcAft>
+                <a:spcPts val="500"/>
+              </a:spcAft>
+            </a:pPr>
+            <a:r>
+              <a:rPr lang="en-US" sz="1400" dirty="0">
+                <a:solidFill>
+                  <a:srgbClr val="13131A"/>
+                </a:solidFill>
+              </a:rPr>
+              <a:t>The ratio of success to failure probability:</a:t>
+            </a:r>
+            <a:endParaRPr lang="en-US" sz="1400" dirty="0"/>
+          </a:p>
+          <a:p>
+            <a:pPr>
+              <a:spcBef>
+                <a:spcPts val="500"/>
+              </a:spcBef>
+              <a:spcAft>
+                <a:spcPts val="500"/>
+              </a:spcAft>
+            </a:pPr>
+            <a:r>
+              <a:rPr lang="en-US" sz="1500" dirty="0">
+                <a:solidFill>
+                  <a:srgbClr val="13131A"/>
+                </a:solidFill>
+                <a:latin typeface="Cambria Math"/>
+              </a:rPr>
+              <a:t>odds(x) = p / (1 − p)</a:t>
+            </a:r>
+            <a:endParaRPr lang="en-US" sz="1500" dirty="0"/>
+          </a:p>
+          <a:p>
+            <a:pPr>
+              <a:spcBef>
+                <a:spcPts val="500"/>
+              </a:spcBef>
+              <a:spcAft>
+                <a:spcPts val="500"/>
+              </a:spcAft>
+            </a:pPr>
+            <a:r>
+              <a:rPr lang="en-US" sz="1500" dirty="0">
+                <a:solidFill>
+                  <a:srgbClr val="13131A"/>
+                </a:solidFill>
+                <a:latin typeface="Cambria Math"/>
+              </a:rPr>
+              <a:t>p ∈ (0,1)  ⇒  odds ∈ (0, ∞)</a:t>
+            </a:r>
+            <a:endParaRPr lang="en-US" sz="1500" dirty="0"/>
+          </a:p>
+          <a:p>
+            <a:pPr>
+              <a:spcBef>
+                <a:spcPts val="500"/>
+              </a:spcBef>
+              <a:spcAft>
+                <a:spcPts val="500"/>
+              </a:spcAft>
+            </a:pPr>
+            <a:r>
+              <a:rPr lang="en-US" sz="1400" dirty="0">
+                <a:solidFill>
+                  <a:srgbClr val="13131A"/>
+                </a:solidFill>
+              </a:rPr>
+              <a:t>A probability of 0.2 is odds of 0.25 — one default for every four non-defaults.</a:t>
+            </a:r>
+            <a:endParaRPr lang="en-US" sz="1400" dirty="0"/>
+          </a:p>
+          <a:p>
+            <a:pPr>
+              <a:spcBef>
+                <a:spcPts val="500"/>
+              </a:spcBef>
+              <a:spcAft>
+                <a:spcPts val="500"/>
+              </a:spcAft>
+            </a:pPr>
+            <a:r>
+              <a:rPr lang="en-US" sz="1400" dirty="0">
+                <a:solidFill>
+                  <a:srgbClr val="13131A"/>
+                </a:solidFill>
+              </a:rPr>
+              <a:t>Odds rescale a probability onto (0, ∞), but they are still not linear in the features.</a:t>
+            </a:r>
+            <a:endParaRPr lang="en-US" sz="1400" dirty="0"/>
+          </a:p>
+        </p:txBody>
+      </p:sp>
+      <p:sp>
+        <p:nvSpPr>
+          <p:cNvPr id="5" name="TextBox 4"/>
+          <p:cNvSpPr txBox="1"/>
+          <p:nvPr/>
+        </p:nvSpPr>
+        <p:spPr>
+          <a:xfrm>
+            <a:off x="6310800" y="1900000"/>
+            <a:ext cx="3900000" cy="2900000"/>
+          </a:xfrm>
+          <a:prstGeom prst="rect">
+            <a:avLst/>
+          </a:prstGeom>
+          <a:noFill/>
+        </p:spPr>
+        <p:txBody>
+          <a:bodyPr wrap="square">
+            <a:spAutoFit/>
+          </a:bodyPr>
+          <a:lstStyle/>
+          <a:p>
+            <a:pPr>
+              <a:spcBef>
+                <a:spcPts val="500"/>
+              </a:spcBef>
+              <a:spcAft>
+                <a:spcPts val="500"/>
+              </a:spcAft>
+            </a:pPr>
+            <a:r>
+              <a:rPr lang="en-US" sz="1600" b="1">
+                <a:solidFill>
+                  <a:srgbClr val="13131A"/>
+                </a:solidFill>
+              </a:rPr>
+              <a:t>Log-odds (the logit)</a:t>
+            </a:r>
+            <a:endParaRPr lang="en-US" sz="1600"/>
+          </a:p>
+          <a:p>
+            <a:pPr>
+              <a:spcBef>
+                <a:spcPts val="500"/>
+              </a:spcBef>
+              <a:spcAft>
+                <a:spcPts val="500"/>
+              </a:spcAft>
+            </a:pPr>
+            <a:r>
+              <a:rPr lang="en-US" sz="1400">
+                <a:solidFill>
+                  <a:srgbClr val="13131A"/>
+                </a:solidFill>
+              </a:rPr>
+              <a:t>The sigmoid and the logit are exact inverses — each undoes the other:</a:t>
+            </a:r>
+            <a:endParaRPr lang="en-US" sz="1400"/>
+          </a:p>
+          <a:p>
+            <a:pPr>
+              <a:spcBef>
+                <a:spcPts val="500"/>
+              </a:spcBef>
+              <a:spcAft>
+                <a:spcPts val="500"/>
+              </a:spcAft>
+            </a:pPr>
+            <a:r>
+              <a:rPr lang="en-US" sz="1500">
+                <a:solidFill>
+                  <a:srgbClr val="13131A"/>
+                </a:solidFill>
+                <a:latin typeface="Cambria Math"/>
+              </a:rPr>
+              <a:t>p = σ(wᵀx + b)   ⟺   logit(p) = wᵀx + b</a:t>
+            </a:r>
+            <a:endParaRPr lang="en-US" sz="1500"/>
+          </a:p>
+          <a:p>
+            <a:pPr>
+              <a:spcBef>
+                <a:spcPts val="500"/>
+              </a:spcBef>
+              <a:spcAft>
+                <a:spcPts val="500"/>
+              </a:spcAft>
+            </a:pPr>
+            <a:r>
+              <a:rPr lang="en-US" sz="1400">
+                <a:solidFill>
+                  <a:srgbClr val="13131A"/>
+                </a:solidFill>
+                <a:latin typeface="Cambria Math"/>
+              </a:rPr>
+              <a:t>where  logit(p) = log( p / (1 − p) )</a:t>
+            </a:r>
+            <a:endParaRPr lang="en-US" sz="1400"/>
+          </a:p>
+          <a:p>
+            <a:pPr>
+              <a:spcBef>
+                <a:spcPts val="500"/>
+              </a:spcBef>
+              <a:spcAft>
+                <a:spcPts val="500"/>
+              </a:spcAft>
+            </a:pPr>
+            <a:r>
+              <a:rPr lang="en-US" sz="1400">
+                <a:solidFill>
+                  <a:srgbClr val="13131A"/>
+                </a:solidFill>
+                <a:latin typeface="Cambria Math"/>
+              </a:rPr>
+              <a:t>and  σ(z) = 1 / (1 + e⁻ᶻ)</a:t>
+            </a:r>
+            <a:endParaRPr lang="en-US" sz="1400"/>
+          </a:p>
+          <a:p>
+            <a:pPr>
+              <a:spcBef>
+                <a:spcPts val="500"/>
+              </a:spcBef>
+              <a:spcAft>
+                <a:spcPts val="500"/>
+              </a:spcAft>
+            </a:pPr>
+            <a:r>
+              <a:rPr lang="en-US" sz="1400">
+                <a:solidFill>
+                  <a:srgbClr val="13131A"/>
+                </a:solidFill>
+              </a:rPr>
+              <a:t>σ carries a log-odds score into a probability; the logit carries a probability back to the score.</a:t>
+            </a:r>
+            <a:endParaRPr lang="en-US" sz="1400"/>
+          </a:p>
+        </p:txBody>
+      </p:sp>
+      <p:sp>
+        <p:nvSpPr>
+          <p:cNvPr id="6" name="TextBox 5"/>
+          <p:cNvSpPr txBox="1"/>
+          <p:nvPr/>
+        </p:nvSpPr>
+        <p:spPr>
+          <a:xfrm>
+            <a:off x="1981200" y="5050000"/>
+            <a:ext cx="8229600" cy="553998"/>
+          </a:xfrm>
+          <a:prstGeom prst="rect">
+            <a:avLst/>
+          </a:prstGeom>
+          <a:noFill/>
+        </p:spPr>
+        <p:txBody>
+          <a:bodyPr wrap="square">
+            <a:spAutoFit/>
+          </a:bodyPr>
+          <a:lstStyle/>
+          <a:p>
+            <a:pPr>
+              <a:spcBef>
+                <a:spcPts val="500"/>
+              </a:spcBef>
+              <a:spcAft>
+                <a:spcPts val="500"/>
+              </a:spcAft>
+            </a:pPr>
+            <a:r>
+              <a:rPr lang="en-US" sz="1500" dirty="0">
+                <a:solidFill>
+                  <a:srgbClr val="13131A"/>
+                </a:solidFill>
+              </a:rPr>
+              <a:t>Taking the log is what makes the scale linear — logistic regression is a linear model on the log-odds scale.</a:t>
+            </a:r>
+            <a:endParaRPr lang="en-US" sz="1500" dirty="0"/>
+          </a:p>
+        </p:txBody>
+      </p:sp>
+    </p:spTree>
+  </p:cSld>
+  <p:clrMapOvr>
+    <a:masterClrMapping/>
+  </p:clrMapOvr>
+</p:sld>
+</file>
+
 <file path=ppt/slides/slide7.xml><?xml version="1.0" encoding="utf-8"?>
 <p:sld xmlns:a="http://schemas.openxmlformats.org/drawingml/2006/main" xmlns:r="http://schemas.openxmlformats.org/officeDocument/2006/relationships" xmlns:p="http://schemas.openxmlformats.org/presentationml/2006/main">
   <p:cSld>
@@ -9740,7 +9571,7 @@
                 </a:solidFill>
                 <a:latin typeface="+mj-lt"/>
               </a:rPr>
-              <a:t>Odds and the Logit</a:t>
+              <a:t>Reading the Coefficients</a:t>
             </a:r>
           </a:p>
         </p:txBody>
@@ -9753,8 +9584,8 @@
         </p:nvSpPr>
         <p:spPr>
           <a:xfrm>
-            <a:off x="1981200" y="1900000"/>
-            <a:ext cx="3900000" cy="2518638"/>
+            <a:off x="1981200" y="1880000"/>
+            <a:ext cx="8229600" cy="4039567"/>
           </a:xfrm>
           <a:prstGeom prst="rect">
             <a:avLst/>
@@ -9769,30 +9600,91 @@
           <a:p>
             <a:pPr>
               <a:spcBef>
-                <a:spcPts val="500"/>
-              </a:spcBef>
-              <a:spcAft>
-                <a:spcPts val="500"/>
-              </a:spcAft>
-            </a:pPr>
-            <a:r>
-              <a:rPr lang="en-US" sz="1600" b="1" dirty="0">
-                <a:solidFill>
-                  <a:srgbClr val="13131A"/>
-                </a:solidFill>
-              </a:rPr>
-              <a:t>Odds</a:t>
-            </a:r>
-            <a:endParaRPr lang="en-US" sz="1600" dirty="0"/>
+                <a:spcPts val="200"/>
+              </a:spcBef>
+              <a:spcAft>
+                <a:spcPts val="200"/>
+              </a:spcAft>
+              <a:buNone/>
+            </a:pPr>
+            <a:r>
+              <a:rPr lang="en-US" sz="1400" dirty="0">
+                <a:solidFill>
+                  <a:srgbClr val="13131A"/>
+                </a:solidFill>
+              </a:rPr>
+              <a:t>The log-odds is an ordinary linear equation:</a:t>
+            </a:r>
+            <a:endParaRPr lang="en-US" sz="1400" dirty="0"/>
+          </a:p>
+          <a:p>
+            <a:pPr marL="342900" indent="0">
+              <a:spcBef>
+                <a:spcPts val="200"/>
+              </a:spcBef>
+              <a:spcAft>
+                <a:spcPts val="200"/>
+              </a:spcAft>
+              <a:buNone/>
+            </a:pPr>
+            <a:r>
+              <a:rPr lang="en-US" sz="1500" dirty="0">
+                <a:solidFill>
+                  <a:srgbClr val="13131A"/>
+                </a:solidFill>
+                <a:latin typeface="Cambria Math"/>
+              </a:rPr>
+              <a:t>logit(p) = log( p / (1 − p) ) = </a:t>
+            </a:r>
+            <a:r>
+              <a:rPr lang="en-US" sz="1500" dirty="0" err="1">
+                <a:solidFill>
+                  <a:srgbClr val="13131A"/>
+                </a:solidFill>
+                <a:latin typeface="Cambria Math"/>
+              </a:rPr>
+              <a:t>wᵀx</a:t>
+            </a:r>
+            <a:r>
+              <a:rPr lang="en-US" sz="1500" dirty="0">
+                <a:solidFill>
+                  <a:srgbClr val="13131A"/>
+                </a:solidFill>
+                <a:latin typeface="Cambria Math"/>
+              </a:rPr>
+              <a:t> + b</a:t>
+            </a:r>
+            <a:endParaRPr lang="en-US" sz="1500" dirty="0"/>
+          </a:p>
+          <a:p>
+            <a:pPr marL="342900" indent="0">
+              <a:spcBef>
+                <a:spcPts val="200"/>
+              </a:spcBef>
+              <a:spcAft>
+                <a:spcPts val="200"/>
+              </a:spcAft>
+              <a:buNone/>
+            </a:pPr>
+            <a:r>
+              <a:rPr lang="en-US" sz="1400" dirty="0">
+                <a:solidFill>
+                  <a:srgbClr val="13131A"/>
+                </a:solidFill>
+              </a:rPr>
+              <a:t>So read wⱼ exactly as a coefficient in linear regression — the change in the response for a one-unit increase in xⱼ, holding the others fixed. The only difference is that the response is the log-odds.</a:t>
+            </a:r>
+            <a:endParaRPr lang="en-US" sz="1400" dirty="0"/>
           </a:p>
           <a:p>
             <a:pPr>
               <a:spcBef>
-                <a:spcPts val="500"/>
-              </a:spcBef>
-              <a:spcAft>
-                <a:spcPts val="500"/>
-              </a:spcAft>
+                <a:spcPts val="300"/>
+              </a:spcBef>
+              <a:spcAft>
+                <a:spcPts val="200"/>
+              </a:spcAft>
+              <a:buNone/>
             </a:pPr>
             <a:r>
               <a:rPr lang="en-US" sz="1400" dirty="0">
@@ -9800,58 +9692,181 @@
                   <a:srgbClr val="13131A"/>
                 </a:solidFill>
               </a:rPr>
-              <a:t>The ratio of success to failure probability:</a:t>
+              <a:t>Exponentiate to move to the odds scale:</a:t>
             </a:r>
             <a:endParaRPr lang="en-US" sz="1400" dirty="0"/>
           </a:p>
           <a:p>
+            <a:pPr marL="342900" indent="0">
+              <a:spcBef>
+                <a:spcPts val="200"/>
+              </a:spcBef>
+              <a:spcAft>
+                <a:spcPts val="200"/>
+              </a:spcAft>
+              <a:buNone/>
+            </a:pPr>
+            <a:r>
+              <a:rPr lang="en-US" sz="1500" dirty="0">
+                <a:solidFill>
+                  <a:srgbClr val="13131A"/>
+                </a:solidFill>
+                <a:latin typeface="Cambria Math"/>
+              </a:rPr>
+              <a:t>odds = p / (1 − p) = exp(</a:t>
+            </a:r>
+            <a:r>
+              <a:rPr lang="en-US" sz="1500" dirty="0" err="1">
+                <a:solidFill>
+                  <a:srgbClr val="13131A"/>
+                </a:solidFill>
+                <a:latin typeface="Cambria Math"/>
+              </a:rPr>
+              <a:t>wᵀx</a:t>
+            </a:r>
+            <a:r>
+              <a:rPr lang="en-US" sz="1500" dirty="0">
+                <a:solidFill>
+                  <a:srgbClr val="13131A"/>
+                </a:solidFill>
+                <a:latin typeface="Cambria Math"/>
+              </a:rPr>
+              <a:t> + b)</a:t>
+            </a:r>
+            <a:endParaRPr lang="en-US" sz="1500" dirty="0"/>
+          </a:p>
+          <a:p>
+            <a:pPr marL="342900" indent="0">
+              <a:spcBef>
+                <a:spcPts val="200"/>
+              </a:spcBef>
+              <a:spcAft>
+                <a:spcPts val="350"/>
+              </a:spcAft>
+              <a:buNone/>
+            </a:pPr>
+            <a:r>
+              <a:rPr lang="en-US" sz="1400" dirty="0">
+                <a:solidFill>
+                  <a:srgbClr val="13131A"/>
+                </a:solidFill>
+              </a:rPr>
+              <a:t>A one-unit increase in xⱼ therefore multiplies the odds by exp(wⱼ) — the odds ratio.</a:t>
+            </a:r>
+            <a:endParaRPr lang="en-US" sz="1400" dirty="0"/>
+          </a:p>
+          <a:p>
             <a:pPr>
               <a:spcBef>
-                <a:spcPts val="500"/>
-              </a:spcBef>
-              <a:spcAft>
-                <a:spcPts val="500"/>
-              </a:spcAft>
-            </a:pPr>
-            <a:r>
-              <a:rPr lang="en-US" sz="1500" dirty="0">
-                <a:solidFill>
-                  <a:srgbClr val="13131A"/>
-                </a:solidFill>
-                <a:latin typeface="Cambria Math"/>
-              </a:rPr>
-              <a:t>odds(x) = p / (1 − p)</a:t>
+                <a:spcPts val="350"/>
+              </a:spcBef>
+              <a:spcAft>
+                <a:spcPts val="200"/>
+              </a:spcAft>
+              <a:buNone/>
+            </a:pPr>
+            <a:r>
+              <a:rPr lang="en-US" sz="1500" b="1" dirty="0">
+                <a:solidFill>
+                  <a:srgbClr val="13131A"/>
+                </a:solidFill>
+              </a:rPr>
+              <a:t>Rules of thumb</a:t>
             </a:r>
             <a:endParaRPr lang="en-US" sz="1500" dirty="0"/>
           </a:p>
           <a:p>
+            <a:pPr marL="342900" indent="-342900">
+              <a:spcBef>
+                <a:spcPts val="200"/>
+              </a:spcBef>
+              <a:spcAft>
+                <a:spcPts val="200"/>
+              </a:spcAft>
+              <a:buFont typeface="Arial" panose="020B0604020202020204" pitchFamily="34" charset="0"/>
+              <a:buChar char="•"/>
+            </a:pPr>
+            <a:r>
+              <a:rPr lang="en-US" sz="1400" dirty="0">
+                <a:solidFill>
+                  <a:srgbClr val="13131A"/>
+                </a:solidFill>
+              </a:rPr>
+              <a:t>wⱼ &gt; 0 raises the probability of y = 1;  wⱼ &lt; 0 lowers it;  wⱼ = 0 means no effect</a:t>
+            </a:r>
+            <a:endParaRPr lang="en-US" sz="1400" dirty="0"/>
+          </a:p>
+          <a:p>
+            <a:pPr marL="342900" indent="-342900">
+              <a:spcBef>
+                <a:spcPts val="200"/>
+              </a:spcBef>
+              <a:spcAft>
+                <a:spcPts val="200"/>
+              </a:spcAft>
+              <a:buFont typeface="Arial" panose="020B0604020202020204" pitchFamily="34" charset="0"/>
+              <a:buChar char="•"/>
+            </a:pPr>
+            <a:r>
+              <a:rPr lang="en-US" sz="1400" dirty="0">
+                <a:solidFill>
+                  <a:srgbClr val="13131A"/>
+                </a:solidFill>
+              </a:rPr>
+              <a:t>wⱼ = 0.7 ⇒ exp(0.7) ≈ 2, so each unit of xⱼ roughly doubles the odds</a:t>
+            </a:r>
+            <a:endParaRPr lang="en-US" sz="1400" dirty="0"/>
+          </a:p>
+          <a:p>
+            <a:pPr marL="342900" indent="-342900">
+              <a:spcBef>
+                <a:spcPts val="200"/>
+              </a:spcBef>
+              <a:spcAft>
+                <a:spcPts val="200"/>
+              </a:spcAft>
+              <a:buFont typeface="Arial" panose="020B0604020202020204" pitchFamily="34" charset="0"/>
+              <a:buChar char="•"/>
+            </a:pPr>
+            <a:r>
+              <a:rPr lang="en-US" sz="1400" dirty="0">
+                <a:solidFill>
+                  <a:srgbClr val="13131A"/>
+                </a:solidFill>
+              </a:rPr>
+              <a:t>Default example: w = 2.0 for balance (in $1,000s) ⇒ exp(2.0) ≈ 7.4, so each extra $1,000 multiplies the odds of default by about 7.4</a:t>
+            </a:r>
+            <a:endParaRPr lang="en-US" sz="1400" dirty="0"/>
+          </a:p>
+          <a:p>
             <a:pPr>
               <a:spcBef>
-                <a:spcPts val="500"/>
-              </a:spcBef>
-              <a:spcAft>
-                <a:spcPts val="500"/>
-              </a:spcAft>
-            </a:pPr>
-            <a:r>
-              <a:rPr lang="en-US" sz="1500" dirty="0">
-                <a:solidFill>
-                  <a:srgbClr val="13131A"/>
-                </a:solidFill>
-                <a:latin typeface="Cambria Math"/>
-              </a:rPr>
-              <a:t>p ∈ (0,1)  ⇒  odds ∈ (0, ∞)</a:t>
+                <a:spcPts val="350"/>
+              </a:spcBef>
+              <a:spcAft>
+                <a:spcPts val="200"/>
+              </a:spcAft>
+              <a:buNone/>
+            </a:pPr>
+            <a:r>
+              <a:rPr lang="en-US" sz="1500" b="1" dirty="0">
+                <a:solidFill>
+                  <a:srgbClr val="13131A"/>
+                </a:solidFill>
+              </a:rPr>
+              <a:t>Note</a:t>
             </a:r>
             <a:endParaRPr lang="en-US" sz="1500" dirty="0"/>
           </a:p>
           <a:p>
             <a:pPr>
               <a:spcBef>
-                <a:spcPts val="500"/>
-              </a:spcBef>
-              <a:spcAft>
-                <a:spcPts val="500"/>
-              </a:spcAft>
+                <a:spcPts val="200"/>
+              </a:spcBef>
+              <a:spcAft>
+                <a:spcPts val="200"/>
+              </a:spcAft>
+              <a:buNone/>
             </a:pPr>
             <a:r>
               <a:rPr lang="en-US" sz="1400" dirty="0">
@@ -9859,210 +9874,9 @@
                   <a:srgbClr val="13131A"/>
                 </a:solidFill>
               </a:rPr>
-              <a:t>A probability of 0.2 is odds of 0.25 — one default for every four non-defaults.</a:t>
+              <a:t>Coefficients are not changes in probability — the same odds ratio moves a probability a lot near 0.5 and very little near 0 or 1.</a:t>
             </a:r>
             <a:endParaRPr lang="en-US" sz="1400" dirty="0"/>
-          </a:p>
-          <a:p>
-            <a:pPr>
-              <a:spcBef>
-                <a:spcPts val="500"/>
-              </a:spcBef>
-              <a:spcAft>
-                <a:spcPts val="500"/>
-              </a:spcAft>
-            </a:pPr>
-            <a:r>
-              <a:rPr lang="en-US" sz="1400" dirty="0">
-                <a:solidFill>
-                  <a:srgbClr val="13131A"/>
-                </a:solidFill>
-              </a:rPr>
-              <a:t>Odds rescale a probability onto (0, ∞), but they are still not linear in the features.</a:t>
-            </a:r>
-            <a:endParaRPr lang="en-US" sz="1400" dirty="0"/>
-          </a:p>
-        </p:txBody>
-      </p:sp>
-      <p:sp>
-        <p:nvSpPr>
-          <p:cNvPr id="5" name="TextBox 4"/>
-          <p:cNvSpPr txBox="1"/>
-          <p:nvPr/>
-        </p:nvSpPr>
-        <p:spPr>
-          <a:xfrm>
-            <a:off x="6310800" y="1900000"/>
-            <a:ext cx="3900000" cy="2900000"/>
-          </a:xfrm>
-          <a:prstGeom prst="rect">
-            <a:avLst/>
-          </a:prstGeom>
-          <a:noFill/>
-        </p:spPr>
-        <p:txBody>
-          <a:bodyPr wrap="square">
-            <a:spAutoFit/>
-          </a:bodyPr>
-          <a:lstStyle/>
-          <a:p>
-            <a:pPr>
-              <a:spcBef>
-                <a:spcPts val="500"/>
-              </a:spcBef>
-              <a:spcAft>
-                <a:spcPts val="500"/>
-              </a:spcAft>
-            </a:pPr>
-            <a:r>
-              <a:rPr lang="en-US" sz="1600" b="1">
-                <a:solidFill>
-                  <a:srgbClr val="13131A"/>
-                </a:solidFill>
-              </a:rPr>
-              <a:t>Log-odds (the logit)</a:t>
-            </a:r>
-            <a:endParaRPr lang="en-US" sz="1600"/>
-          </a:p>
-          <a:p>
-            <a:pPr>
-              <a:spcBef>
-                <a:spcPts val="500"/>
-              </a:spcBef>
-              <a:spcAft>
-                <a:spcPts val="500"/>
-              </a:spcAft>
-            </a:pPr>
-            <a:r>
-              <a:rPr lang="en-US" sz="1400">
-                <a:solidFill>
-                  <a:srgbClr val="13131A"/>
-                </a:solidFill>
-              </a:rPr>
-              <a:t>The sigmoid and the logit are exact inverses — each undoes the other:</a:t>
-            </a:r>
-            <a:endParaRPr lang="en-US" sz="1400"/>
-          </a:p>
-          <a:p>
-            <a:pPr>
-              <a:spcBef>
-                <a:spcPts val="500"/>
-              </a:spcBef>
-              <a:spcAft>
-                <a:spcPts val="500"/>
-              </a:spcAft>
-            </a:pPr>
-            <a:r>
-              <a:rPr lang="en-US" sz="1500">
-                <a:solidFill>
-                  <a:srgbClr val="13131A"/>
-                </a:solidFill>
-                <a:latin typeface="Cambria Math"/>
-              </a:rPr>
-              <a:t>p = σ(wᵀx + b)   ⟺   logit(p) = wᵀx + b</a:t>
-            </a:r>
-            <a:endParaRPr lang="en-US" sz="1500"/>
-          </a:p>
-          <a:p>
-            <a:pPr>
-              <a:spcBef>
-                <a:spcPts val="500"/>
-              </a:spcBef>
-              <a:spcAft>
-                <a:spcPts val="500"/>
-              </a:spcAft>
-            </a:pPr>
-            <a:r>
-              <a:rPr lang="en-US" sz="1400">
-                <a:solidFill>
-                  <a:srgbClr val="13131A"/>
-                </a:solidFill>
-                <a:latin typeface="Cambria Math"/>
-              </a:rPr>
-              <a:t>where  logit(p) = log( p / (1 − p) )</a:t>
-            </a:r>
-            <a:endParaRPr lang="en-US" sz="1400"/>
-          </a:p>
-          <a:p>
-            <a:pPr>
-              <a:spcBef>
-                <a:spcPts val="500"/>
-              </a:spcBef>
-              <a:spcAft>
-                <a:spcPts val="500"/>
-              </a:spcAft>
-            </a:pPr>
-            <a:r>
-              <a:rPr lang="en-US" sz="1400">
-                <a:solidFill>
-                  <a:srgbClr val="13131A"/>
-                </a:solidFill>
-                <a:latin typeface="Cambria Math"/>
-              </a:rPr>
-              <a:t>and  σ(z) = 1 / (1 + e⁻ᶻ)</a:t>
-            </a:r>
-            <a:endParaRPr lang="en-US" sz="1400"/>
-          </a:p>
-          <a:p>
-            <a:pPr>
-              <a:spcBef>
-                <a:spcPts val="500"/>
-              </a:spcBef>
-              <a:spcAft>
-                <a:spcPts val="500"/>
-              </a:spcAft>
-            </a:pPr>
-            <a:r>
-              <a:rPr lang="en-US" sz="1400">
-                <a:solidFill>
-                  <a:srgbClr val="13131A"/>
-                </a:solidFill>
-              </a:rPr>
-              <a:t>σ carries a log-odds score into a probability; the logit carries a probability back to the score.</a:t>
-            </a:r>
-            <a:endParaRPr lang="en-US" sz="1400"/>
-          </a:p>
-        </p:txBody>
-      </p:sp>
-      <p:sp>
-        <p:nvSpPr>
-          <p:cNvPr id="6" name="TextBox 5"/>
-          <p:cNvSpPr txBox="1"/>
-          <p:nvPr/>
-        </p:nvSpPr>
-        <p:spPr>
-          <a:xfrm>
-            <a:off x="1981200" y="5050000"/>
-            <a:ext cx="8229600" cy="553998"/>
-          </a:xfrm>
-          <a:prstGeom prst="rect">
-            <a:avLst/>
-          </a:prstGeom>
-          <a:noFill/>
-        </p:spPr>
-        <p:txBody>
-          <a:bodyPr wrap="square">
-            <a:spAutoFit/>
-          </a:bodyPr>
-          <a:lstStyle/>
-          <a:p>
-            <a:pPr>
-              <a:spcBef>
-                <a:spcPts val="500"/>
-              </a:spcBef>
-              <a:spcAft>
-                <a:spcPts val="500"/>
-              </a:spcAft>
-            </a:pPr>
-            <a:r>
-              <a:rPr lang="en-US" sz="1500" dirty="0">
-                <a:solidFill>
-                  <a:srgbClr val="13131A"/>
-                </a:solidFill>
-              </a:rPr>
-              <a:t>Taking the log is what makes the scale linear — logistic regression is a linear model on the log-odds scale.</a:t>
-            </a:r>
-            <a:endParaRPr lang="en-US" sz="1500" dirty="0"/>
           </a:p>
         </p:txBody>
       </p:sp>
@@ -10114,16 +9928,16 @@
           <a:lstStyle/>
           <a:p>
             <a:pPr>
-              <a:defRPr sz="3600" b="1"/>
-            </a:pPr>
-            <a:r>
-              <a:rPr lang="en-US" sz="3600" b="1" cap="all">
+              <a:defRPr sz="3200" b="1"/>
+            </a:pPr>
+            <a:r>
+              <a:rPr lang="en-US" sz="3200" b="1" cap="all">
                 <a:solidFill>
                   <a:srgbClr val="13131A"/>
                 </a:solidFill>
                 <a:latin typeface="+mj-lt"/>
               </a:rPr>
-              <a:t>Reading the Coefficients</a:t>
+              <a:t>Part 2 — Fitting the Model</a:t>
             </a:r>
           </a:p>
         </p:txBody>
@@ -10136,8 +9950,8 @@
         </p:nvSpPr>
         <p:spPr>
           <a:xfrm>
-            <a:off x="1981200" y="1880000"/>
-            <a:ext cx="8229600" cy="4039567"/>
+            <a:off x="1981200" y="2100000"/>
+            <a:ext cx="8229600" cy="4083169"/>
           </a:xfrm>
           <a:prstGeom prst="rect">
             <a:avLst/>
@@ -10152,283 +9966,78 @@
           <a:p>
             <a:pPr>
               <a:spcBef>
-                <a:spcPts val="200"/>
-              </a:spcBef>
-              <a:spcAft>
-                <a:spcPts val="200"/>
-              </a:spcAft>
-              <a:buNone/>
-            </a:pPr>
-            <a:r>
-              <a:rPr lang="en-US" sz="1400" dirty="0">
-                <a:solidFill>
-                  <a:srgbClr val="13131A"/>
-                </a:solidFill>
-              </a:rPr>
-              <a:t>The log-odds is an ordinary linear equation:</a:t>
-            </a:r>
-            <a:endParaRPr lang="en-US" sz="1400" dirty="0"/>
-          </a:p>
-          <a:p>
-            <a:pPr marL="342900" indent="0">
-              <a:spcBef>
-                <a:spcPts val="200"/>
-              </a:spcBef>
-              <a:spcAft>
-                <a:spcPts val="200"/>
-              </a:spcAft>
-              <a:buNone/>
-            </a:pPr>
-            <a:r>
-              <a:rPr lang="en-US" sz="1500" dirty="0">
-                <a:solidFill>
-                  <a:srgbClr val="13131A"/>
-                </a:solidFill>
-                <a:latin typeface="Cambria Math"/>
-              </a:rPr>
-              <a:t>logit(p) = log( p / (1 − p) ) = </a:t>
-            </a:r>
-            <a:r>
-              <a:rPr lang="en-US" sz="1500" dirty="0" err="1">
-                <a:solidFill>
-                  <a:srgbClr val="13131A"/>
-                </a:solidFill>
-                <a:latin typeface="Cambria Math"/>
-              </a:rPr>
-              <a:t>wᵀx</a:t>
-            </a:r>
-            <a:r>
-              <a:rPr lang="en-US" sz="1500" dirty="0">
-                <a:solidFill>
-                  <a:srgbClr val="13131A"/>
-                </a:solidFill>
-                <a:latin typeface="Cambria Math"/>
-              </a:rPr>
-              <a:t> + b</a:t>
-            </a:r>
-            <a:endParaRPr lang="en-US" sz="1500" dirty="0"/>
-          </a:p>
-          <a:p>
-            <a:pPr marL="342900" indent="0">
-              <a:spcBef>
-                <a:spcPts val="200"/>
-              </a:spcBef>
-              <a:spcAft>
-                <a:spcPts val="200"/>
-              </a:spcAft>
-              <a:buNone/>
-            </a:pPr>
-            <a:r>
-              <a:rPr lang="en-US" sz="1400" dirty="0">
-                <a:solidFill>
-                  <a:srgbClr val="13131A"/>
-                </a:solidFill>
-              </a:rPr>
-              <a:t>So read wⱼ exactly as a coefficient in linear regression — the change in the response for a one-unit increase in xⱼ, holding the others fixed. The only difference is that the response is the log-odds.</a:t>
-            </a:r>
-            <a:endParaRPr lang="en-US" sz="1400" dirty="0"/>
+                <a:spcPts val="500"/>
+              </a:spcBef>
+              <a:spcAft>
+                <a:spcPts val="500"/>
+              </a:spcAft>
+            </a:pPr>
+            <a:r>
+              <a:rPr lang="en-US" sz="1800" b="1">
+                <a:solidFill>
+                  <a:srgbClr val="13131A"/>
+                </a:solidFill>
+              </a:rPr>
+              <a:t>From a model to fitted values of w and b.</a:t>
+            </a:r>
+            <a:endParaRPr lang="en-US" sz="1800"/>
           </a:p>
           <a:p>
             <a:pPr>
               <a:spcBef>
-                <a:spcPts val="300"/>
-              </a:spcBef>
-              <a:spcAft>
-                <a:spcPts val="200"/>
-              </a:spcAft>
-              <a:buNone/>
-            </a:pPr>
-            <a:r>
-              <a:rPr lang="en-US" sz="1400" dirty="0">
-                <a:solidFill>
-                  <a:srgbClr val="13131A"/>
-                </a:solidFill>
-              </a:rPr>
-              <a:t>Exponentiate to move to the odds scale:</a:t>
-            </a:r>
-            <a:endParaRPr lang="en-US" sz="1400" dirty="0"/>
-          </a:p>
-          <a:p>
-            <a:pPr marL="342900" indent="0">
-              <a:spcBef>
-                <a:spcPts val="200"/>
-              </a:spcBef>
-              <a:spcAft>
-                <a:spcPts val="200"/>
-              </a:spcAft>
-              <a:buNone/>
-            </a:pPr>
-            <a:r>
-              <a:rPr lang="en-US" sz="1500" dirty="0">
-                <a:solidFill>
-                  <a:srgbClr val="13131A"/>
-                </a:solidFill>
-                <a:latin typeface="Cambria Math"/>
-              </a:rPr>
-              <a:t>odds = p / (1 − p) = exp(</a:t>
-            </a:r>
-            <a:r>
-              <a:rPr lang="en-US" sz="1500" dirty="0" err="1">
-                <a:solidFill>
-                  <a:srgbClr val="13131A"/>
-                </a:solidFill>
-                <a:latin typeface="Cambria Math"/>
-              </a:rPr>
-              <a:t>wᵀx</a:t>
-            </a:r>
-            <a:r>
-              <a:rPr lang="en-US" sz="1500" dirty="0">
-                <a:solidFill>
-                  <a:srgbClr val="13131A"/>
-                </a:solidFill>
-                <a:latin typeface="Cambria Math"/>
-              </a:rPr>
-              <a:t> + b)</a:t>
-            </a:r>
-            <a:endParaRPr lang="en-US" sz="1500" dirty="0"/>
-          </a:p>
-          <a:p>
-            <a:pPr marL="342900" indent="0">
-              <a:spcBef>
-                <a:spcPts val="200"/>
-              </a:spcBef>
-              <a:spcAft>
-                <a:spcPts val="350"/>
-              </a:spcAft>
-              <a:buNone/>
-            </a:pPr>
-            <a:r>
-              <a:rPr lang="en-US" sz="1400" dirty="0">
-                <a:solidFill>
-                  <a:srgbClr val="13131A"/>
-                </a:solidFill>
-              </a:rPr>
-              <a:t>A one-unit increase in xⱼ therefore multiplies the odds by exp(wⱼ) — the odds ratio.</a:t>
-            </a:r>
-            <a:endParaRPr lang="en-US" sz="1400" dirty="0"/>
+                <a:spcPts val="500"/>
+              </a:spcBef>
+              <a:spcAft>
+                <a:spcPts val="500"/>
+              </a:spcAft>
+            </a:pPr>
+            <a:r>
+              <a:rPr lang="en-US" sz="1500">
+                <a:solidFill>
+                  <a:srgbClr val="13131A"/>
+                </a:solidFill>
+              </a:rPr>
+              <a:t>•  What probability model generated the data?</a:t>
+            </a:r>
+            <a:endParaRPr lang="en-US" sz="1500"/>
           </a:p>
           <a:p>
             <a:pPr>
               <a:spcBef>
-                <a:spcPts val="350"/>
-              </a:spcBef>
-              <a:spcAft>
-                <a:spcPts val="200"/>
-              </a:spcAft>
-              <a:buNone/>
-            </a:pPr>
-            <a:r>
-              <a:rPr lang="en-US" sz="1500" b="1" dirty="0">
-                <a:solidFill>
-                  <a:srgbClr val="13131A"/>
-                </a:solidFill>
-              </a:rPr>
-              <a:t>Rules of thumb</a:t>
-            </a:r>
-            <a:endParaRPr lang="en-US" sz="1500" dirty="0"/>
-          </a:p>
-          <a:p>
-            <a:pPr marL="342900" indent="-342900">
-              <a:spcBef>
-                <a:spcPts val="200"/>
-              </a:spcBef>
-              <a:spcAft>
-                <a:spcPts val="200"/>
-              </a:spcAft>
-              <a:buFont typeface="Arial" panose="020B0604020202020204" pitchFamily="34" charset="0"/>
-              <a:buChar char="•"/>
-            </a:pPr>
-            <a:r>
-              <a:rPr lang="en-US" sz="1400" dirty="0">
-                <a:solidFill>
-                  <a:srgbClr val="13131A"/>
-                </a:solidFill>
-              </a:rPr>
-              <a:t>wⱼ &gt; 0 raises the probability of y = 1;  wⱼ &lt; 0 lowers it;  wⱼ = 0 means no effect</a:t>
-            </a:r>
-            <a:endParaRPr lang="en-US" sz="1400" dirty="0"/>
-          </a:p>
-          <a:p>
-            <a:pPr marL="342900" indent="-342900">
-              <a:spcBef>
-                <a:spcPts val="200"/>
-              </a:spcBef>
-              <a:spcAft>
-                <a:spcPts val="200"/>
-              </a:spcAft>
-              <a:buFont typeface="Arial" panose="020B0604020202020204" pitchFamily="34" charset="0"/>
-              <a:buChar char="•"/>
-            </a:pPr>
-            <a:r>
-              <a:rPr lang="en-US" sz="1400" dirty="0">
-                <a:solidFill>
-                  <a:srgbClr val="13131A"/>
-                </a:solidFill>
-              </a:rPr>
-              <a:t>wⱼ = 0.7 ⇒ exp(0.7) ≈ 2, so each unit of xⱼ roughly doubles the odds</a:t>
-            </a:r>
-            <a:endParaRPr lang="en-US" sz="1400" dirty="0"/>
-          </a:p>
-          <a:p>
-            <a:pPr marL="342900" indent="-342900">
-              <a:spcBef>
-                <a:spcPts val="200"/>
-              </a:spcBef>
-              <a:spcAft>
-                <a:spcPts val="200"/>
-              </a:spcAft>
-              <a:buFont typeface="Arial" panose="020B0604020202020204" pitchFamily="34" charset="0"/>
-              <a:buChar char="•"/>
-            </a:pPr>
-            <a:r>
-              <a:rPr lang="en-US" sz="1400" dirty="0">
-                <a:solidFill>
-                  <a:srgbClr val="13131A"/>
-                </a:solidFill>
-              </a:rPr>
-              <a:t>Default example: w = 2.0 for balance (in $1,000s) ⇒ exp(2.0) ≈ 7.4, so each extra $1,000 multiplies the odds of default by about 7.4</a:t>
-            </a:r>
-            <a:endParaRPr lang="en-US" sz="1400" dirty="0"/>
+                <a:spcPts val="500"/>
+              </a:spcBef>
+              <a:spcAft>
+                <a:spcPts val="500"/>
+              </a:spcAft>
+            </a:pPr>
+            <a:r>
+              <a:rPr lang="en-US" sz="1500">
+                <a:solidFill>
+                  <a:srgbClr val="13131A"/>
+                </a:solidFill>
+              </a:rPr>
+              <a:t>•  What objective does that model imply?</a:t>
+            </a:r>
+            <a:endParaRPr lang="en-US" sz="1500"/>
           </a:p>
           <a:p>
             <a:pPr>
               <a:spcBef>
-                <a:spcPts val="350"/>
-              </a:spcBef>
-              <a:spcAft>
-                <a:spcPts val="200"/>
-              </a:spcAft>
-              <a:buNone/>
-            </a:pPr>
-            <a:r>
-              <a:rPr lang="en-US" sz="1500" b="1" dirty="0">
-                <a:solidFill>
-                  <a:srgbClr val="13131A"/>
-                </a:solidFill>
-              </a:rPr>
-              <a:t>Note</a:t>
-            </a:r>
-            <a:endParaRPr lang="en-US" sz="1500" dirty="0"/>
-          </a:p>
-          <a:p>
-            <a:pPr>
-              <a:spcBef>
-                <a:spcPts val="200"/>
-              </a:spcBef>
-              <a:spcAft>
-                <a:spcPts val="200"/>
-              </a:spcAft>
-              <a:buNone/>
-            </a:pPr>
-            <a:r>
-              <a:rPr lang="en-US" sz="1400" dirty="0">
-                <a:solidFill>
-                  <a:srgbClr val="13131A"/>
-                </a:solidFill>
-              </a:rPr>
-              <a:t>Coefficients are not changes in probability — the same odds ratio moves a probability a lot near 0.5 and very little near 0 or 1.</a:t>
-            </a:r>
-            <a:endParaRPr lang="en-US" sz="1400" dirty="0"/>
+                <a:spcPts val="500"/>
+              </a:spcBef>
+              <a:spcAft>
+                <a:spcPts val="500"/>
+              </a:spcAft>
+            </a:pPr>
+            <a:r>
+              <a:rPr lang="en-US" sz="1500">
+                <a:solidFill>
+                  <a:srgbClr val="13131A"/>
+                </a:solidFill>
+              </a:rPr>
+              <a:t>•  How do we minimize it when there is no closed form?</a:t>
+            </a:r>
+            <a:endParaRPr lang="en-US" sz="1500"/>
           </a:p>
         </p:txBody>
       </p:sp>
@@ -10480,16 +10089,16 @@
           <a:lstStyle/>
           <a:p>
             <a:pPr>
-              <a:defRPr sz="3200" b="1"/>
-            </a:pPr>
-            <a:r>
-              <a:rPr lang="en-US" sz="3200" b="1" cap="all">
+              <a:defRPr sz="3600" b="1"/>
+            </a:pPr>
+            <a:r>
+              <a:rPr lang="en-US" sz="3600" b="1" cap="all">
                 <a:solidFill>
                   <a:srgbClr val="13131A"/>
                 </a:solidFill>
                 <a:latin typeface="+mj-lt"/>
               </a:rPr>
-              <a:t>Part 2 — Fitting the Model</a:t>
+              <a:t>The Bernoulli Model</a:t>
             </a:r>
           </a:p>
         </p:txBody>
@@ -10502,8 +10111,8 @@
         </p:nvSpPr>
         <p:spPr>
           <a:xfrm>
-            <a:off x="1981200" y="2100000"/>
-            <a:ext cx="8229600" cy="4083169"/>
+            <a:off x="1981200" y="1950000"/>
+            <a:ext cx="8229600" cy="2395528"/>
           </a:xfrm>
           <a:prstGeom prst="rect">
             <a:avLst/>
@@ -10525,14 +10134,14 @@
               </a:spcAft>
             </a:pPr>
             <a:r>
-              <a:rPr lang="en-US" sz="1800" b="1">
-                <a:solidFill>
-                  <a:srgbClr val="13131A"/>
-                </a:solidFill>
-              </a:rPr>
-              <a:t>From a model to fitted values of w and b.</a:t>
-            </a:r>
-            <a:endParaRPr lang="en-US" sz="1800"/>
+              <a:rPr lang="en-US" sz="1500" dirty="0">
+                <a:solidFill>
+                  <a:srgbClr val="13131A"/>
+                </a:solidFill>
+              </a:rPr>
+              <a:t>Explicitly model the data-generating process:</a:t>
+            </a:r>
+            <a:endParaRPr lang="en-US" sz="1500" dirty="0"/>
           </a:p>
           <a:p>
             <a:pPr>
@@ -10544,14 +10153,33 @@
               </a:spcAft>
             </a:pPr>
             <a:r>
-              <a:rPr lang="en-US" sz="1500">
-                <a:solidFill>
-                  <a:srgbClr val="13131A"/>
-                </a:solidFill>
-              </a:rPr>
-              <a:t>•  What probability model generated the data?</a:t>
-            </a:r>
-            <a:endParaRPr lang="en-US" sz="1500"/>
+              <a:rPr lang="en-US" sz="1700" dirty="0">
+                <a:solidFill>
+                  <a:srgbClr val="13131A"/>
+                </a:solidFill>
+                <a:latin typeface="Cambria Math"/>
+              </a:rPr>
+              <a:t>y | x  ~  Bernoulli(p),    p = σ(</a:t>
+            </a:r>
+            <a:r>
+              <a:rPr lang="en-US" sz="1700" dirty="0" err="1">
+                <a:solidFill>
+                  <a:srgbClr val="13131A"/>
+                </a:solidFill>
+                <a:latin typeface="Cambria Math"/>
+              </a:rPr>
+              <a:t>wᵀx</a:t>
+            </a:r>
+            <a:r>
+              <a:rPr lang="en-US" sz="1700" dirty="0">
+                <a:solidFill>
+                  <a:srgbClr val="13131A"/>
+                </a:solidFill>
+                <a:latin typeface="Cambria Math"/>
+              </a:rPr>
+              <a:t> + b)</a:t>
+            </a:r>
+            <a:endParaRPr lang="en-US" sz="1700" dirty="0"/>
           </a:p>
           <a:p>
             <a:pPr>
@@ -10563,14 +10191,14 @@
               </a:spcAft>
             </a:pPr>
             <a:r>
-              <a:rPr lang="en-US" sz="1500">
-                <a:solidFill>
-                  <a:srgbClr val="13131A"/>
-                </a:solidFill>
-              </a:rPr>
-              <a:t>•  What objective does that model imply?</a:t>
-            </a:r>
-            <a:endParaRPr lang="en-US" sz="1500"/>
+              <a:rPr lang="en-US" sz="1500" dirty="0">
+                <a:solidFill>
+                  <a:srgbClr val="13131A"/>
+                </a:solidFill>
+              </a:rPr>
+              <a:t>A Bernoulli random variable equals 1 with probability p and 0 with probability 1 − p — a single weighted coin flip. Each customer either defaults or does not; the model sets the bias of that coin.</a:t>
+            </a:r>
+            <a:endParaRPr lang="en-US" sz="1500" dirty="0"/>
           </a:p>
           <a:p>
             <a:pPr>
@@ -10582,14 +10210,56 @@
               </a:spcAft>
             </a:pPr>
             <a:r>
-              <a:rPr lang="en-US" sz="1500">
-                <a:solidFill>
-                  <a:srgbClr val="13131A"/>
-                </a:solidFill>
-              </a:rPr>
-              <a:t>•  How do we minimize it when there is no closed form?</a:t>
-            </a:r>
-            <a:endParaRPr lang="en-US" sz="1500"/>
+              <a:rPr lang="en-US" sz="1600" b="1" dirty="0">
+                <a:solidFill>
+                  <a:srgbClr val="13131A"/>
+                </a:solidFill>
+              </a:rPr>
+              <a:t>Why this choice</a:t>
+            </a:r>
+            <a:endParaRPr lang="en-US" sz="1600" dirty="0"/>
+          </a:p>
+          <a:p>
+            <a:pPr marL="285750" indent="-285750">
+              <a:spcBef>
+                <a:spcPts val="500"/>
+              </a:spcBef>
+              <a:spcAft>
+                <a:spcPts val="500"/>
+              </a:spcAft>
+              <a:buFont typeface="Arial" panose="020B0604020202020204" pitchFamily="34" charset="0"/>
+              <a:buChar char="•"/>
+            </a:pPr>
+            <a:r>
+              <a:rPr lang="en-US" sz="1500" dirty="0">
+                <a:solidFill>
+                  <a:srgbClr val="13131A"/>
+                </a:solidFill>
+              </a:rPr>
+              <a:t>It matches the binary nature of the data</a:t>
+            </a:r>
+            <a:endParaRPr lang="en-US" sz="1500" dirty="0"/>
+          </a:p>
+          <a:p>
+            <a:pPr marL="285750" indent="-285750">
+              <a:spcBef>
+                <a:spcPts val="500"/>
+              </a:spcBef>
+              <a:spcAft>
+                <a:spcPts val="500"/>
+              </a:spcAft>
+              <a:buFont typeface="Arial" panose="020B0604020202020204" pitchFamily="34" charset="0"/>
+              <a:buChar char="•"/>
+            </a:pPr>
+            <a:r>
+              <a:rPr lang="en-US" sz="1500" dirty="0">
+                <a:solidFill>
+                  <a:srgbClr val="13131A"/>
+                </a:solidFill>
+              </a:rPr>
+              <a:t>It gives a principled, likelihood-based</a:t>
+            </a:r>
+            <a:endParaRPr lang="en-US" sz="1500" dirty="0"/>
           </a:p>
         </p:txBody>
       </p:sp>

</xml_diff>